<commit_message>
Updated PLS analysis table
</commit_message>
<xml_diff>
--- a/output/cross_stage_concordance/panelA_nonnegative_CLM_bootstrap.pptx
+++ b/output/cross_stage_concordance/panelA_nonnegative_CLM_bootstrap.pptx
@@ -7,7 +7,7 @@
   <p:sldIdLst>
     <p:sldId id="256" r:id="rId8"/>
   </p:sldIdLst>
-  <p:sldSz cx="9144000" cy="6858000" type="screen4x3"/>
+  <p:sldSz cx="6400800" cy="5852160" type="screen4x3"/>
   <p:notesSz cx="6858000" cy="9144000"/>
   <p:custDataLst>
     <p:tags r:id="rId3"/>
@@ -2271,8 +2271,8 @@
           </p:nvSpPr>
           <p:spPr>
             <a:xfrm>
-              <a:off x="744102" y="0"/>
-              <a:ext cx="4912594" cy="5852160"/>
+              <a:off x="742136" y="0"/>
+              <a:ext cx="4916526" cy="5852160"/>
             </a:xfrm>
             <a:prstGeom prst="rect">
               <a:avLst/>
@@ -2297,8 +2297,8 @@
           </p:nvSpPr>
           <p:spPr>
             <a:xfrm>
-              <a:off x="1194397" y="1030002"/>
-              <a:ext cx="4392710" cy="4392710"/>
+              <a:off x="1237877" y="1030002"/>
+              <a:ext cx="4351197" cy="4351197"/>
             </a:xfrm>
             <a:prstGeom prst="rect">
               <a:avLst/>
@@ -2323,8 +2323,8 @@
           </p:nvSpPr>
           <p:spPr>
             <a:xfrm>
-              <a:off x="1265247" y="4643361"/>
-              <a:ext cx="708501" cy="708501"/>
+              <a:off x="1308057" y="4609213"/>
+              <a:ext cx="701805" cy="701805"/>
             </a:xfrm>
             <a:prstGeom prst="rect">
               <a:avLst/>
@@ -2358,8 +2358,8 @@
           </p:nvSpPr>
           <p:spPr>
             <a:xfrm>
-              <a:off x="1973749" y="4643361"/>
-              <a:ext cx="708501" cy="708501"/>
+              <a:off x="2009863" y="4609213"/>
+              <a:ext cx="701805" cy="701805"/>
             </a:xfrm>
             <a:prstGeom prst="rect">
               <a:avLst/>
@@ -2393,8 +2393,8 @@
           </p:nvSpPr>
           <p:spPr>
             <a:xfrm>
-              <a:off x="2682251" y="4643361"/>
-              <a:ext cx="708501" cy="708501"/>
+              <a:off x="2711669" y="4609213"/>
+              <a:ext cx="701805" cy="701805"/>
             </a:xfrm>
             <a:prstGeom prst="rect">
               <a:avLst/>
@@ -2428,8 +2428,8 @@
           </p:nvSpPr>
           <p:spPr>
             <a:xfrm>
-              <a:off x="3390752" y="4643361"/>
-              <a:ext cx="708501" cy="708501"/>
+              <a:off x="3413475" y="4609213"/>
+              <a:ext cx="701805" cy="701805"/>
             </a:xfrm>
             <a:prstGeom prst="rect">
               <a:avLst/>
@@ -2463,8 +2463,8 @@
           </p:nvSpPr>
           <p:spPr>
             <a:xfrm>
-              <a:off x="4099254" y="4643361"/>
-              <a:ext cx="708501" cy="708501"/>
+              <a:off x="4115281" y="4609213"/>
+              <a:ext cx="701805" cy="701805"/>
             </a:xfrm>
             <a:prstGeom prst="rect">
               <a:avLst/>
@@ -2498,8 +2498,8 @@
           </p:nvSpPr>
           <p:spPr>
             <a:xfrm>
-              <a:off x="4807756" y="4643361"/>
-              <a:ext cx="708501" cy="708501"/>
+              <a:off x="4817087" y="4609213"/>
+              <a:ext cx="701805" cy="701805"/>
             </a:xfrm>
             <a:prstGeom prst="rect">
               <a:avLst/>
@@ -2533,8 +2533,8 @@
           </p:nvSpPr>
           <p:spPr>
             <a:xfrm>
-              <a:off x="1265247" y="3934859"/>
-              <a:ext cx="708501" cy="708501"/>
+              <a:off x="1308057" y="3907407"/>
+              <a:ext cx="701805" cy="701805"/>
             </a:xfrm>
             <a:prstGeom prst="rect">
               <a:avLst/>
@@ -2568,8 +2568,8 @@
           </p:nvSpPr>
           <p:spPr>
             <a:xfrm>
-              <a:off x="1973749" y="3934859"/>
-              <a:ext cx="708501" cy="708501"/>
+              <a:off x="2009863" y="3907407"/>
+              <a:ext cx="701805" cy="701805"/>
             </a:xfrm>
             <a:prstGeom prst="rect">
               <a:avLst/>
@@ -2603,8 +2603,8 @@
           </p:nvSpPr>
           <p:spPr>
             <a:xfrm>
-              <a:off x="2682251" y="3934859"/>
-              <a:ext cx="708501" cy="708501"/>
+              <a:off x="2711669" y="3907407"/>
+              <a:ext cx="701805" cy="701805"/>
             </a:xfrm>
             <a:prstGeom prst="rect">
               <a:avLst/>
@@ -2638,8 +2638,8 @@
           </p:nvSpPr>
           <p:spPr>
             <a:xfrm>
-              <a:off x="3390752" y="3934859"/>
-              <a:ext cx="708501" cy="708501"/>
+              <a:off x="3413475" y="3907407"/>
+              <a:ext cx="701805" cy="701805"/>
             </a:xfrm>
             <a:prstGeom prst="rect">
               <a:avLst/>
@@ -2673,8 +2673,8 @@
           </p:nvSpPr>
           <p:spPr>
             <a:xfrm>
-              <a:off x="4099254" y="3934859"/>
-              <a:ext cx="708501" cy="708501"/>
+              <a:off x="4115281" y="3907407"/>
+              <a:ext cx="701805" cy="701805"/>
             </a:xfrm>
             <a:prstGeom prst="rect">
               <a:avLst/>
@@ -2708,8 +2708,8 @@
           </p:nvSpPr>
           <p:spPr>
             <a:xfrm>
-              <a:off x="4807756" y="3934859"/>
-              <a:ext cx="708501" cy="708501"/>
+              <a:off x="4817087" y="3907407"/>
+              <a:ext cx="701805" cy="701805"/>
             </a:xfrm>
             <a:prstGeom prst="rect">
               <a:avLst/>
@@ -2743,8 +2743,8 @@
           </p:nvSpPr>
           <p:spPr>
             <a:xfrm>
-              <a:off x="1265247" y="3226358"/>
-              <a:ext cx="708501" cy="708501"/>
+              <a:off x="1308057" y="3205601"/>
+              <a:ext cx="701805" cy="701805"/>
             </a:xfrm>
             <a:prstGeom prst="rect">
               <a:avLst/>
@@ -2778,8 +2778,8 @@
           </p:nvSpPr>
           <p:spPr>
             <a:xfrm>
-              <a:off x="1973749" y="3226358"/>
-              <a:ext cx="708501" cy="708501"/>
+              <a:off x="2009863" y="3205601"/>
+              <a:ext cx="701805" cy="701805"/>
             </a:xfrm>
             <a:prstGeom prst="rect">
               <a:avLst/>
@@ -2813,8 +2813,8 @@
           </p:nvSpPr>
           <p:spPr>
             <a:xfrm>
-              <a:off x="2682251" y="3226358"/>
-              <a:ext cx="708501" cy="708501"/>
+              <a:off x="2711669" y="3205601"/>
+              <a:ext cx="701805" cy="701805"/>
             </a:xfrm>
             <a:prstGeom prst="rect">
               <a:avLst/>
@@ -2848,8 +2848,8 @@
           </p:nvSpPr>
           <p:spPr>
             <a:xfrm>
-              <a:off x="3390752" y="3226358"/>
-              <a:ext cx="708501" cy="708501"/>
+              <a:off x="3413475" y="3205601"/>
+              <a:ext cx="701805" cy="701805"/>
             </a:xfrm>
             <a:prstGeom prst="rect">
               <a:avLst/>
@@ -2883,8 +2883,8 @@
           </p:nvSpPr>
           <p:spPr>
             <a:xfrm>
-              <a:off x="4099254" y="3226358"/>
-              <a:ext cx="708501" cy="708501"/>
+              <a:off x="4115281" y="3205601"/>
+              <a:ext cx="701805" cy="701805"/>
             </a:xfrm>
             <a:prstGeom prst="rect">
               <a:avLst/>
@@ -2918,8 +2918,8 @@
           </p:nvSpPr>
           <p:spPr>
             <a:xfrm>
-              <a:off x="4807756" y="3226358"/>
-              <a:ext cx="708501" cy="708501"/>
+              <a:off x="4817087" y="3205601"/>
+              <a:ext cx="701805" cy="701805"/>
             </a:xfrm>
             <a:prstGeom prst="rect">
               <a:avLst/>
@@ -2953,8 +2953,8 @@
           </p:nvSpPr>
           <p:spPr>
             <a:xfrm>
-              <a:off x="1265247" y="2517856"/>
-              <a:ext cx="708501" cy="708501"/>
+              <a:off x="1308057" y="2503795"/>
+              <a:ext cx="701805" cy="701805"/>
             </a:xfrm>
             <a:prstGeom prst="rect">
               <a:avLst/>
@@ -2988,8 +2988,8 @@
           </p:nvSpPr>
           <p:spPr>
             <a:xfrm>
-              <a:off x="1973749" y="2517856"/>
-              <a:ext cx="708501" cy="708501"/>
+              <a:off x="2009863" y="2503795"/>
+              <a:ext cx="701805" cy="701805"/>
             </a:xfrm>
             <a:prstGeom prst="rect">
               <a:avLst/>
@@ -3023,8 +3023,8 @@
           </p:nvSpPr>
           <p:spPr>
             <a:xfrm>
-              <a:off x="2682251" y="2517856"/>
-              <a:ext cx="708501" cy="708501"/>
+              <a:off x="2711669" y="2503795"/>
+              <a:ext cx="701805" cy="701805"/>
             </a:xfrm>
             <a:prstGeom prst="rect">
               <a:avLst/>
@@ -3058,8 +3058,8 @@
           </p:nvSpPr>
           <p:spPr>
             <a:xfrm>
-              <a:off x="3390752" y="2517856"/>
-              <a:ext cx="708501" cy="708501"/>
+              <a:off x="3413475" y="2503795"/>
+              <a:ext cx="701805" cy="701805"/>
             </a:xfrm>
             <a:prstGeom prst="rect">
               <a:avLst/>
@@ -3093,8 +3093,8 @@
           </p:nvSpPr>
           <p:spPr>
             <a:xfrm>
-              <a:off x="4099254" y="2517856"/>
-              <a:ext cx="708501" cy="708501"/>
+              <a:off x="4115281" y="2503795"/>
+              <a:ext cx="701805" cy="701805"/>
             </a:xfrm>
             <a:prstGeom prst="rect">
               <a:avLst/>
@@ -3128,8 +3128,8 @@
           </p:nvSpPr>
           <p:spPr>
             <a:xfrm>
-              <a:off x="4807756" y="2517856"/>
-              <a:ext cx="708501" cy="708501"/>
+              <a:off x="4817087" y="2503795"/>
+              <a:ext cx="701805" cy="701805"/>
             </a:xfrm>
             <a:prstGeom prst="rect">
               <a:avLst/>
@@ -3163,8 +3163,8 @@
           </p:nvSpPr>
           <p:spPr>
             <a:xfrm>
-              <a:off x="1265247" y="1809354"/>
-              <a:ext cx="708501" cy="708501"/>
+              <a:off x="1308057" y="1801989"/>
+              <a:ext cx="701805" cy="701805"/>
             </a:xfrm>
             <a:prstGeom prst="rect">
               <a:avLst/>
@@ -3198,8 +3198,8 @@
           </p:nvSpPr>
           <p:spPr>
             <a:xfrm>
-              <a:off x="1973749" y="1809354"/>
-              <a:ext cx="708501" cy="708501"/>
+              <a:off x="2009863" y="1801989"/>
+              <a:ext cx="701805" cy="701805"/>
             </a:xfrm>
             <a:prstGeom prst="rect">
               <a:avLst/>
@@ -3233,8 +3233,8 @@
           </p:nvSpPr>
           <p:spPr>
             <a:xfrm>
-              <a:off x="2682251" y="1809354"/>
-              <a:ext cx="708501" cy="708501"/>
+              <a:off x="2711669" y="1801989"/>
+              <a:ext cx="701805" cy="701805"/>
             </a:xfrm>
             <a:prstGeom prst="rect">
               <a:avLst/>
@@ -3268,8 +3268,8 @@
           </p:nvSpPr>
           <p:spPr>
             <a:xfrm>
-              <a:off x="3390752" y="1809354"/>
-              <a:ext cx="708501" cy="708501"/>
+              <a:off x="3413475" y="1801989"/>
+              <a:ext cx="701805" cy="701805"/>
             </a:xfrm>
             <a:prstGeom prst="rect">
               <a:avLst/>
@@ -3303,8 +3303,8 @@
           </p:nvSpPr>
           <p:spPr>
             <a:xfrm>
-              <a:off x="4099254" y="1809354"/>
-              <a:ext cx="708501" cy="708501"/>
+              <a:off x="4115281" y="1801989"/>
+              <a:ext cx="701805" cy="701805"/>
             </a:xfrm>
             <a:prstGeom prst="rect">
               <a:avLst/>
@@ -3338,8 +3338,8 @@
           </p:nvSpPr>
           <p:spPr>
             <a:xfrm>
-              <a:off x="4807756" y="1809354"/>
-              <a:ext cx="708501" cy="708501"/>
+              <a:off x="4817087" y="1801989"/>
+              <a:ext cx="701805" cy="701805"/>
             </a:xfrm>
             <a:prstGeom prst="rect">
               <a:avLst/>
@@ -3373,8 +3373,8 @@
           </p:nvSpPr>
           <p:spPr>
             <a:xfrm>
-              <a:off x="1265247" y="1100852"/>
-              <a:ext cx="708501" cy="708501"/>
+              <a:off x="1308057" y="1100183"/>
+              <a:ext cx="701805" cy="701805"/>
             </a:xfrm>
             <a:prstGeom prst="rect">
               <a:avLst/>
@@ -3408,8 +3408,8 @@
           </p:nvSpPr>
           <p:spPr>
             <a:xfrm>
-              <a:off x="1973749" y="1100852"/>
-              <a:ext cx="708501" cy="708501"/>
+              <a:off x="2009863" y="1100183"/>
+              <a:ext cx="701805" cy="701805"/>
             </a:xfrm>
             <a:prstGeom prst="rect">
               <a:avLst/>
@@ -3443,8 +3443,8 @@
           </p:nvSpPr>
           <p:spPr>
             <a:xfrm>
-              <a:off x="2682251" y="1100852"/>
-              <a:ext cx="708501" cy="708501"/>
+              <a:off x="2711669" y="1100183"/>
+              <a:ext cx="701805" cy="701805"/>
             </a:xfrm>
             <a:prstGeom prst="rect">
               <a:avLst/>
@@ -3478,8 +3478,8 @@
           </p:nvSpPr>
           <p:spPr>
             <a:xfrm>
-              <a:off x="3390752" y="1100852"/>
-              <a:ext cx="708501" cy="708501"/>
+              <a:off x="3413475" y="1100183"/>
+              <a:ext cx="701805" cy="701805"/>
             </a:xfrm>
             <a:prstGeom prst="rect">
               <a:avLst/>
@@ -3513,8 +3513,8 @@
           </p:nvSpPr>
           <p:spPr>
             <a:xfrm>
-              <a:off x="4099254" y="1100852"/>
-              <a:ext cx="708501" cy="708501"/>
+              <a:off x="4115281" y="1100183"/>
+              <a:ext cx="701805" cy="701805"/>
             </a:xfrm>
             <a:prstGeom prst="rect">
               <a:avLst/>
@@ -3548,8 +3548,8 @@
           </p:nvSpPr>
           <p:spPr>
             <a:xfrm>
-              <a:off x="4807756" y="1100852"/>
-              <a:ext cx="708501" cy="708501"/>
+              <a:off x="4817087" y="1100183"/>
+              <a:ext cx="701805" cy="701805"/>
             </a:xfrm>
             <a:prstGeom prst="rect">
               <a:avLst/>
@@ -3583,8 +3583,8 @@
           </p:nvSpPr>
           <p:spPr>
             <a:xfrm>
-              <a:off x="1477355" y="4956921"/>
-              <a:ext cx="284286" cy="81381"/>
+              <a:off x="1489659" y="4911652"/>
+              <a:ext cx="338602" cy="96926"/>
             </a:xfrm>
             <a:prstGeom prst="rect">
               <a:avLst/>
@@ -3604,7 +3604,7 @@
                 </a:spcAft>
               </a:pPr>
               <a:r>
-                <a:rPr sz="896" i="0" b="0">
+                <a:rPr sz="1066" i="0" b="0">
                   <a:solidFill>
                     <a:srgbClr val="000000">
                       <a:alpha val="100000"/>
@@ -3626,8 +3626,8 @@
           </p:nvSpPr>
           <p:spPr>
             <a:xfrm>
-              <a:off x="2185856" y="4956921"/>
-              <a:ext cx="284286" cy="81381"/>
+              <a:off x="2191465" y="4911652"/>
+              <a:ext cx="338602" cy="96926"/>
             </a:xfrm>
             <a:prstGeom prst="rect">
               <a:avLst/>
@@ -3647,7 +3647,7 @@
                 </a:spcAft>
               </a:pPr>
               <a:r>
-                <a:rPr sz="896" i="0" b="0">
+                <a:rPr sz="1066" i="0" b="0">
                   <a:solidFill>
                     <a:srgbClr val="000000">
                       <a:alpha val="100000"/>
@@ -3669,8 +3669,8 @@
           </p:nvSpPr>
           <p:spPr>
             <a:xfrm>
-              <a:off x="2925951" y="4956921"/>
-              <a:ext cx="221101" cy="81381"/>
+              <a:off x="2930899" y="4911652"/>
+              <a:ext cx="263347" cy="96926"/>
             </a:xfrm>
             <a:prstGeom prst="rect">
               <a:avLst/>
@@ -3690,7 +3690,7 @@
                 </a:spcAft>
               </a:pPr>
               <a:r>
-                <a:rPr sz="896" i="0" b="0">
+                <a:rPr sz="1066" i="0" b="0">
                   <a:solidFill>
                     <a:srgbClr val="000000">
                       <a:alpha val="100000"/>
@@ -3712,8 +3712,8 @@
           </p:nvSpPr>
           <p:spPr>
             <a:xfrm>
-              <a:off x="3607066" y="4956921"/>
-              <a:ext cx="275874" cy="81381"/>
+              <a:off x="3600106" y="4911652"/>
+              <a:ext cx="328543" cy="96926"/>
             </a:xfrm>
             <a:prstGeom prst="rect">
               <a:avLst/>
@@ -3733,7 +3733,7 @@
                 </a:spcAft>
               </a:pPr>
               <a:r>
-                <a:rPr sz="896" i="0" b="0">
+                <a:rPr sz="1066" i="0" b="0">
                   <a:solidFill>
                     <a:srgbClr val="000000">
                       <a:alpha val="100000"/>
@@ -3755,8 +3755,8 @@
           </p:nvSpPr>
           <p:spPr>
             <a:xfrm>
-              <a:off x="4315568" y="4956921"/>
-              <a:ext cx="275874" cy="81381"/>
+              <a:off x="4301912" y="4911652"/>
+              <a:ext cx="328543" cy="96926"/>
             </a:xfrm>
             <a:prstGeom prst="rect">
               <a:avLst/>
@@ -3776,7 +3776,7 @@
                 </a:spcAft>
               </a:pPr>
               <a:r>
-                <a:rPr sz="896" i="0" b="0">
+                <a:rPr sz="1066" i="0" b="0">
                   <a:solidFill>
                     <a:srgbClr val="000000">
                       <a:alpha val="100000"/>
@@ -3798,8 +3798,8 @@
           </p:nvSpPr>
           <p:spPr>
             <a:xfrm>
-              <a:off x="5019863" y="4956921"/>
-              <a:ext cx="284286" cy="81381"/>
+              <a:off x="4998689" y="4911652"/>
+              <a:ext cx="338602" cy="96926"/>
             </a:xfrm>
             <a:prstGeom prst="rect">
               <a:avLst/>
@@ -3819,7 +3819,7 @@
                 </a:spcAft>
               </a:pPr>
               <a:r>
-                <a:rPr sz="896" i="0" b="0">
+                <a:rPr sz="1066" i="0" b="0">
                   <a:solidFill>
                     <a:srgbClr val="000000">
                       <a:alpha val="100000"/>
@@ -3841,8 +3841,8 @@
           </p:nvSpPr>
           <p:spPr>
             <a:xfrm>
-              <a:off x="1477355" y="4248419"/>
-              <a:ext cx="284286" cy="81381"/>
+              <a:off x="1489659" y="4143177"/>
+              <a:ext cx="338602" cy="96926"/>
             </a:xfrm>
             <a:prstGeom prst="rect">
               <a:avLst/>
@@ -3862,7 +3862,7 @@
                 </a:spcAft>
               </a:pPr>
               <a:r>
-                <a:rPr sz="896" i="0" b="0">
+                <a:rPr sz="1066" i="0" b="0">
                   <a:solidFill>
                     <a:srgbClr val="000000">
                       <a:alpha val="100000"/>
@@ -3884,8 +3884,8 @@
           </p:nvSpPr>
           <p:spPr>
             <a:xfrm>
-              <a:off x="2185856" y="4248419"/>
-              <a:ext cx="284286" cy="81381"/>
+              <a:off x="1640169" y="4276516"/>
+              <a:ext cx="37581" cy="96926"/>
             </a:xfrm>
             <a:prstGeom prst="rect">
               <a:avLst/>
@@ -3905,7 +3905,50 @@
                 </a:spcAft>
               </a:pPr>
               <a:r>
-                <a:rPr sz="896" i="0" b="0">
+                <a:rPr sz="1066" i="0" b="0">
+                  <a:solidFill>
+                    <a:srgbClr val="000000">
+                      <a:alpha val="100000"/>
+                    </a:srgbClr>
+                  </a:solidFill>
+                  <a:latin typeface="Arial"/>
+                  <a:cs typeface="Arial"/>
+                </a:rPr>
+                <a:t>.</a:t>
+              </a:r>
+            </a:p>
+          </p:txBody>
+        </p:sp>
+        <p:sp>
+          <p:nvSpPr>
+            <p:cNvPr id="50" name="tx50"/>
+            <p:cNvSpPr/>
+            <p:nvPr/>
+          </p:nvSpPr>
+          <p:spPr>
+            <a:xfrm>
+              <a:off x="2191465" y="4209846"/>
+              <a:ext cx="338602" cy="96926"/>
+            </a:xfrm>
+            <a:prstGeom prst="rect">
+              <a:avLst/>
+            </a:prstGeom>
+            <a:noFill/>
+          </p:spPr>
+          <p:txBody>
+            <a:bodyPr lIns="0" rIns="0" tIns="0" bIns="0" anchorCtr="1" anchor="ctr" wrap="none"/>
+            <a:lstStyle/>
+            <a:p>
+              <a:pPr algn="l" marL="0" marR="0" indent="0">
+                <a:spcBef>
+                  <a:spcPts val="0"/>
+                </a:spcBef>
+                <a:spcAft>
+                  <a:spcPts val="0"/>
+                </a:spcAft>
+              </a:pPr>
+              <a:r>
+                <a:rPr sz="1066" i="0" b="0">
                   <a:solidFill>
                     <a:srgbClr val="000000">
                       <a:alpha val="100000"/>
@@ -3921,14 +3964,14 @@
         </p:sp>
         <p:sp>
           <p:nvSpPr>
-            <p:cNvPr id="50" name="tx50"/>
-            <p:cNvSpPr/>
-            <p:nvPr/>
-          </p:nvSpPr>
-          <p:spPr>
-            <a:xfrm>
-              <a:off x="2894358" y="4248419"/>
-              <a:ext cx="284286" cy="81381"/>
+            <p:cNvPr id="51" name="tx51"/>
+            <p:cNvSpPr/>
+            <p:nvPr/>
+          </p:nvSpPr>
+          <p:spPr>
+            <a:xfrm>
+              <a:off x="2893271" y="4209846"/>
+              <a:ext cx="338602" cy="96926"/>
             </a:xfrm>
             <a:prstGeom prst="rect">
               <a:avLst/>
@@ -3948,7 +3991,7 @@
                 </a:spcAft>
               </a:pPr>
               <a:r>
-                <a:rPr sz="896" i="0" b="0">
+                <a:rPr sz="1066" i="0" b="0">
                   <a:solidFill>
                     <a:srgbClr val="000000">
                       <a:alpha val="100000"/>
@@ -3964,14 +4007,14 @@
         </p:sp>
         <p:sp>
           <p:nvSpPr>
-            <p:cNvPr id="51" name="tx51"/>
-            <p:cNvSpPr/>
-            <p:nvPr/>
-          </p:nvSpPr>
-          <p:spPr>
-            <a:xfrm>
-              <a:off x="3543881" y="4192417"/>
-              <a:ext cx="402244" cy="81381"/>
+            <p:cNvPr id="52" name="tx52"/>
+            <p:cNvSpPr/>
+            <p:nvPr/>
+          </p:nvSpPr>
+          <p:spPr>
+            <a:xfrm>
+              <a:off x="3524851" y="4143177"/>
+              <a:ext cx="479054" cy="96926"/>
             </a:xfrm>
             <a:prstGeom prst="rect">
               <a:avLst/>
@@ -3991,7 +4034,7 @@
                 </a:spcAft>
               </a:pPr>
               <a:r>
-                <a:rPr sz="896" i="0" b="0">
+                <a:rPr sz="1066" i="0" b="0">
                   <a:solidFill>
                     <a:srgbClr val="000000">
                       <a:alpha val="100000"/>
@@ -4007,14 +4050,14 @@
         </p:sp>
         <p:sp>
           <p:nvSpPr>
-            <p:cNvPr id="52" name="tx52"/>
-            <p:cNvSpPr/>
-            <p:nvPr/>
-          </p:nvSpPr>
-          <p:spPr>
-            <a:xfrm>
-              <a:off x="3722875" y="4304421"/>
-              <a:ext cx="44256" cy="81381"/>
+            <p:cNvPr id="53" name="tx53"/>
+            <p:cNvSpPr/>
+            <p:nvPr/>
+          </p:nvSpPr>
+          <p:spPr>
+            <a:xfrm>
+              <a:off x="3711709" y="4276516"/>
+              <a:ext cx="105338" cy="96926"/>
             </a:xfrm>
             <a:prstGeom prst="rect">
               <a:avLst/>
@@ -4034,7 +4077,1039 @@
                 </a:spcAft>
               </a:pPr>
               <a:r>
-                <a:rPr sz="896" i="0" b="0">
+                <a:rPr sz="1066" i="0" b="0">
+                  <a:solidFill>
+                    <a:srgbClr val="000000">
+                      <a:alpha val="100000"/>
+                    </a:srgbClr>
+                  </a:solidFill>
+                  <a:latin typeface="Arial"/>
+                  <a:cs typeface="Arial"/>
+                </a:rPr>
+                <a:t>**</a:t>
+              </a:r>
+            </a:p>
+          </p:txBody>
+        </p:sp>
+        <p:sp>
+          <p:nvSpPr>
+            <p:cNvPr id="54" name="tx54"/>
+            <p:cNvSpPr/>
+            <p:nvPr/>
+          </p:nvSpPr>
+          <p:spPr>
+            <a:xfrm>
+              <a:off x="4296883" y="4143177"/>
+              <a:ext cx="338602" cy="96926"/>
+            </a:xfrm>
+            <a:prstGeom prst="rect">
+              <a:avLst/>
+            </a:prstGeom>
+            <a:noFill/>
+          </p:spPr>
+          <p:txBody>
+            <a:bodyPr lIns="0" rIns="0" tIns="0" bIns="0" anchorCtr="1" anchor="ctr" wrap="none"/>
+            <a:lstStyle/>
+            <a:p>
+              <a:pPr algn="l" marL="0" marR="0" indent="0">
+                <a:spcBef>
+                  <a:spcPts val="0"/>
+                </a:spcBef>
+                <a:spcAft>
+                  <a:spcPts val="0"/>
+                </a:spcAft>
+              </a:pPr>
+              <a:r>
+                <a:rPr sz="1066" i="0" b="0">
+                  <a:solidFill>
+                    <a:srgbClr val="000000">
+                      <a:alpha val="100000"/>
+                    </a:srgbClr>
+                  </a:solidFill>
+                  <a:latin typeface="Arial"/>
+                  <a:cs typeface="Arial"/>
+                </a:rPr>
+                <a:t>67/78</a:t>
+              </a:r>
+            </a:p>
+          </p:txBody>
+        </p:sp>
+        <p:sp>
+          <p:nvSpPr>
+            <p:cNvPr id="55" name="tx55"/>
+            <p:cNvSpPr/>
+            <p:nvPr/>
+          </p:nvSpPr>
+          <p:spPr>
+            <a:xfrm>
+              <a:off x="4413515" y="4276516"/>
+              <a:ext cx="105338" cy="96926"/>
+            </a:xfrm>
+            <a:prstGeom prst="rect">
+              <a:avLst/>
+            </a:prstGeom>
+            <a:noFill/>
+          </p:spPr>
+          <p:txBody>
+            <a:bodyPr lIns="0" rIns="0" tIns="0" bIns="0" anchorCtr="1" anchor="ctr" wrap="none"/>
+            <a:lstStyle/>
+            <a:p>
+              <a:pPr algn="l" marL="0" marR="0" indent="0">
+                <a:spcBef>
+                  <a:spcPts val="0"/>
+                </a:spcBef>
+                <a:spcAft>
+                  <a:spcPts val="0"/>
+                </a:spcAft>
+              </a:pPr>
+              <a:r>
+                <a:rPr sz="1066" i="0" b="0">
+                  <a:solidFill>
+                    <a:srgbClr val="000000">
+                      <a:alpha val="100000"/>
+                    </a:srgbClr>
+                  </a:solidFill>
+                  <a:latin typeface="Arial"/>
+                  <a:cs typeface="Arial"/>
+                </a:rPr>
+                <a:t>**</a:t>
+              </a:r>
+            </a:p>
+          </p:txBody>
+        </p:sp>
+        <p:sp>
+          <p:nvSpPr>
+            <p:cNvPr id="56" name="tx56"/>
+            <p:cNvSpPr/>
+            <p:nvPr/>
+          </p:nvSpPr>
+          <p:spPr>
+            <a:xfrm>
+              <a:off x="4998689" y="4209846"/>
+              <a:ext cx="338602" cy="96926"/>
+            </a:xfrm>
+            <a:prstGeom prst="rect">
+              <a:avLst/>
+            </a:prstGeom>
+            <a:noFill/>
+          </p:spPr>
+          <p:txBody>
+            <a:bodyPr lIns="0" rIns="0" tIns="0" bIns="0" anchorCtr="1" anchor="ctr" wrap="none"/>
+            <a:lstStyle/>
+            <a:p>
+              <a:pPr algn="l" marL="0" marR="0" indent="0">
+                <a:spcBef>
+                  <a:spcPts val="0"/>
+                </a:spcBef>
+                <a:spcAft>
+                  <a:spcPts val="0"/>
+                </a:spcAft>
+              </a:pPr>
+              <a:r>
+                <a:rPr sz="1066" i="0" b="0">
+                  <a:solidFill>
+                    <a:srgbClr val="000000">
+                      <a:alpha val="100000"/>
+                    </a:srgbClr>
+                  </a:solidFill>
+                  <a:latin typeface="Arial"/>
+                  <a:cs typeface="Arial"/>
+                </a:rPr>
+                <a:t>20/40</a:t>
+              </a:r>
+            </a:p>
+          </p:txBody>
+        </p:sp>
+        <p:sp>
+          <p:nvSpPr>
+            <p:cNvPr id="57" name="tx57"/>
+            <p:cNvSpPr/>
+            <p:nvPr/>
+          </p:nvSpPr>
+          <p:spPr>
+            <a:xfrm>
+              <a:off x="1489659" y="3508040"/>
+              <a:ext cx="338602" cy="96926"/>
+            </a:xfrm>
+            <a:prstGeom prst="rect">
+              <a:avLst/>
+            </a:prstGeom>
+            <a:noFill/>
+          </p:spPr>
+          <p:txBody>
+            <a:bodyPr lIns="0" rIns="0" tIns="0" bIns="0" anchorCtr="1" anchor="ctr" wrap="none"/>
+            <a:lstStyle/>
+            <a:p>
+              <a:pPr algn="l" marL="0" marR="0" indent="0">
+                <a:spcBef>
+                  <a:spcPts val="0"/>
+                </a:spcBef>
+                <a:spcAft>
+                  <a:spcPts val="0"/>
+                </a:spcAft>
+              </a:pPr>
+              <a:r>
+                <a:rPr sz="1066" i="0" b="0">
+                  <a:solidFill>
+                    <a:srgbClr val="000000">
+                      <a:alpha val="100000"/>
+                    </a:srgbClr>
+                  </a:solidFill>
+                  <a:latin typeface="Arial"/>
+                  <a:cs typeface="Arial"/>
+                </a:rPr>
+                <a:t>16/54</a:t>
+              </a:r>
+            </a:p>
+          </p:txBody>
+        </p:sp>
+        <p:sp>
+          <p:nvSpPr>
+            <p:cNvPr id="58" name="tx58"/>
+            <p:cNvSpPr/>
+            <p:nvPr/>
+          </p:nvSpPr>
+          <p:spPr>
+            <a:xfrm>
+              <a:off x="2191465" y="3508040"/>
+              <a:ext cx="338602" cy="96926"/>
+            </a:xfrm>
+            <a:prstGeom prst="rect">
+              <a:avLst/>
+            </a:prstGeom>
+            <a:noFill/>
+          </p:spPr>
+          <p:txBody>
+            <a:bodyPr lIns="0" rIns="0" tIns="0" bIns="0" anchorCtr="1" anchor="ctr" wrap="none"/>
+            <a:lstStyle/>
+            <a:p>
+              <a:pPr algn="l" marL="0" marR="0" indent="0">
+                <a:spcBef>
+                  <a:spcPts val="0"/>
+                </a:spcBef>
+                <a:spcAft>
+                  <a:spcPts val="0"/>
+                </a:spcAft>
+              </a:pPr>
+              <a:r>
+                <a:rPr sz="1066" i="0" b="0">
+                  <a:solidFill>
+                    <a:srgbClr val="000000">
+                      <a:alpha val="100000"/>
+                    </a:srgbClr>
+                  </a:solidFill>
+                  <a:latin typeface="Arial"/>
+                  <a:cs typeface="Arial"/>
+                </a:rPr>
+                <a:t>22/36</a:t>
+              </a:r>
+            </a:p>
+          </p:txBody>
+        </p:sp>
+        <p:sp>
+          <p:nvSpPr>
+            <p:cNvPr id="59" name="tx59"/>
+            <p:cNvSpPr/>
+            <p:nvPr/>
+          </p:nvSpPr>
+          <p:spPr>
+            <a:xfrm>
+              <a:off x="2893271" y="3508040"/>
+              <a:ext cx="338602" cy="96926"/>
+            </a:xfrm>
+            <a:prstGeom prst="rect">
+              <a:avLst/>
+            </a:prstGeom>
+            <a:noFill/>
+          </p:spPr>
+          <p:txBody>
+            <a:bodyPr lIns="0" rIns="0" tIns="0" bIns="0" anchorCtr="1" anchor="ctr" wrap="none"/>
+            <a:lstStyle/>
+            <a:p>
+              <a:pPr algn="l" marL="0" marR="0" indent="0">
+                <a:spcBef>
+                  <a:spcPts val="0"/>
+                </a:spcBef>
+                <a:spcAft>
+                  <a:spcPts val="0"/>
+                </a:spcAft>
+              </a:pPr>
+              <a:r>
+                <a:rPr sz="1066" i="0" b="0">
+                  <a:solidFill>
+                    <a:srgbClr val="000000">
+                      <a:alpha val="100000"/>
+                    </a:srgbClr>
+                  </a:solidFill>
+                  <a:latin typeface="Arial"/>
+                  <a:cs typeface="Arial"/>
+                </a:rPr>
+                <a:t>12/18</a:t>
+              </a:r>
+            </a:p>
+          </p:txBody>
+        </p:sp>
+        <p:sp>
+          <p:nvSpPr>
+            <p:cNvPr id="60" name="tx60"/>
+            <p:cNvSpPr/>
+            <p:nvPr/>
+          </p:nvSpPr>
+          <p:spPr>
+            <a:xfrm>
+              <a:off x="3595077" y="3508040"/>
+              <a:ext cx="338602" cy="96926"/>
+            </a:xfrm>
+            <a:prstGeom prst="rect">
+              <a:avLst/>
+            </a:prstGeom>
+            <a:noFill/>
+          </p:spPr>
+          <p:txBody>
+            <a:bodyPr lIns="0" rIns="0" tIns="0" bIns="0" anchorCtr="1" anchor="ctr" wrap="none"/>
+            <a:lstStyle/>
+            <a:p>
+              <a:pPr algn="l" marL="0" marR="0" indent="0">
+                <a:spcBef>
+                  <a:spcPts val="0"/>
+                </a:spcBef>
+                <a:spcAft>
+                  <a:spcPts val="0"/>
+                </a:spcAft>
+              </a:pPr>
+              <a:r>
+                <a:rPr sz="1066" i="0" b="0">
+                  <a:solidFill>
+                    <a:srgbClr val="000000">
+                      <a:alpha val="100000"/>
+                    </a:srgbClr>
+                  </a:solidFill>
+                  <a:latin typeface="Arial"/>
+                  <a:cs typeface="Arial"/>
+                </a:rPr>
+                <a:t>36/84</a:t>
+              </a:r>
+            </a:p>
+          </p:txBody>
+        </p:sp>
+        <p:sp>
+          <p:nvSpPr>
+            <p:cNvPr id="61" name="tx61"/>
+            <p:cNvSpPr/>
+            <p:nvPr/>
+          </p:nvSpPr>
+          <p:spPr>
+            <a:xfrm>
+              <a:off x="4296883" y="3508040"/>
+              <a:ext cx="338602" cy="96926"/>
+            </a:xfrm>
+            <a:prstGeom prst="rect">
+              <a:avLst/>
+            </a:prstGeom>
+            <a:noFill/>
+          </p:spPr>
+          <p:txBody>
+            <a:bodyPr lIns="0" rIns="0" tIns="0" bIns="0" anchorCtr="1" anchor="ctr" wrap="none"/>
+            <a:lstStyle/>
+            <a:p>
+              <a:pPr algn="l" marL="0" marR="0" indent="0">
+                <a:spcBef>
+                  <a:spcPts val="0"/>
+                </a:spcBef>
+                <a:spcAft>
+                  <a:spcPts val="0"/>
+                </a:spcAft>
+              </a:pPr>
+              <a:r>
+                <a:rPr sz="1066" i="0" b="0">
+                  <a:solidFill>
+                    <a:srgbClr val="000000">
+                      <a:alpha val="100000"/>
+                    </a:srgbClr>
+                  </a:solidFill>
+                  <a:latin typeface="Arial"/>
+                  <a:cs typeface="Arial"/>
+                </a:rPr>
+                <a:t>20/52</a:t>
+              </a:r>
+            </a:p>
+          </p:txBody>
+        </p:sp>
+        <p:sp>
+          <p:nvSpPr>
+            <p:cNvPr id="62" name="tx62"/>
+            <p:cNvSpPr/>
+            <p:nvPr/>
+          </p:nvSpPr>
+          <p:spPr>
+            <a:xfrm>
+              <a:off x="4998689" y="3508040"/>
+              <a:ext cx="338602" cy="96926"/>
+            </a:xfrm>
+            <a:prstGeom prst="rect">
+              <a:avLst/>
+            </a:prstGeom>
+            <a:noFill/>
+          </p:spPr>
+          <p:txBody>
+            <a:bodyPr lIns="0" rIns="0" tIns="0" bIns="0" anchorCtr="1" anchor="ctr" wrap="none"/>
+            <a:lstStyle/>
+            <a:p>
+              <a:pPr algn="l" marL="0" marR="0" indent="0">
+                <a:spcBef>
+                  <a:spcPts val="0"/>
+                </a:spcBef>
+                <a:spcAft>
+                  <a:spcPts val="0"/>
+                </a:spcAft>
+              </a:pPr>
+              <a:r>
+                <a:rPr sz="1066" i="0" b="0">
+                  <a:solidFill>
+                    <a:srgbClr val="000000">
+                      <a:alpha val="100000"/>
+                    </a:srgbClr>
+                  </a:solidFill>
+                  <a:latin typeface="Arial"/>
+                  <a:cs typeface="Arial"/>
+                </a:rPr>
+                <a:t>15/30</a:t>
+              </a:r>
+            </a:p>
+          </p:txBody>
+        </p:sp>
+        <p:sp>
+          <p:nvSpPr>
+            <p:cNvPr id="63" name="tx63"/>
+            <p:cNvSpPr/>
+            <p:nvPr/>
+          </p:nvSpPr>
+          <p:spPr>
+            <a:xfrm>
+              <a:off x="1494688" y="2806234"/>
+              <a:ext cx="328543" cy="96926"/>
+            </a:xfrm>
+            <a:prstGeom prst="rect">
+              <a:avLst/>
+            </a:prstGeom>
+            <a:noFill/>
+          </p:spPr>
+          <p:txBody>
+            <a:bodyPr lIns="0" rIns="0" tIns="0" bIns="0" anchorCtr="1" anchor="ctr" wrap="none"/>
+            <a:lstStyle/>
+            <a:p>
+              <a:pPr algn="l" marL="0" marR="0" indent="0">
+                <a:spcBef>
+                  <a:spcPts val="0"/>
+                </a:spcBef>
+                <a:spcAft>
+                  <a:spcPts val="0"/>
+                </a:spcAft>
+              </a:pPr>
+              <a:r>
+                <a:rPr sz="1066" i="0" b="0">
+                  <a:solidFill>
+                    <a:srgbClr val="000000">
+                      <a:alpha val="100000"/>
+                    </a:srgbClr>
+                  </a:solidFill>
+                  <a:latin typeface="Arial"/>
+                  <a:cs typeface="Arial"/>
+                </a:rPr>
+                <a:t>11/27</a:t>
+              </a:r>
+            </a:p>
+          </p:txBody>
+        </p:sp>
+        <p:sp>
+          <p:nvSpPr>
+            <p:cNvPr id="64" name="tx64"/>
+            <p:cNvSpPr/>
+            <p:nvPr/>
+          </p:nvSpPr>
+          <p:spPr>
+            <a:xfrm>
+              <a:off x="2191465" y="2806234"/>
+              <a:ext cx="338602" cy="96926"/>
+            </a:xfrm>
+            <a:prstGeom prst="rect">
+              <a:avLst/>
+            </a:prstGeom>
+            <a:noFill/>
+          </p:spPr>
+          <p:txBody>
+            <a:bodyPr lIns="0" rIns="0" tIns="0" bIns="0" anchorCtr="1" anchor="ctr" wrap="none"/>
+            <a:lstStyle/>
+            <a:p>
+              <a:pPr algn="l" marL="0" marR="0" indent="0">
+                <a:spcBef>
+                  <a:spcPts val="0"/>
+                </a:spcBef>
+                <a:spcAft>
+                  <a:spcPts val="0"/>
+                </a:spcAft>
+              </a:pPr>
+              <a:r>
+                <a:rPr sz="1066" i="0" b="0">
+                  <a:solidFill>
+                    <a:srgbClr val="000000">
+                      <a:alpha val="100000"/>
+                    </a:srgbClr>
+                  </a:solidFill>
+                  <a:latin typeface="Arial"/>
+                  <a:cs typeface="Arial"/>
+                </a:rPr>
+                <a:t>12/18</a:t>
+              </a:r>
+            </a:p>
+          </p:txBody>
+        </p:sp>
+        <p:sp>
+          <p:nvSpPr>
+            <p:cNvPr id="65" name="tx65"/>
+            <p:cNvSpPr/>
+            <p:nvPr/>
+          </p:nvSpPr>
+          <p:spPr>
+            <a:xfrm>
+              <a:off x="2935928" y="2806234"/>
+              <a:ext cx="253288" cy="96926"/>
+            </a:xfrm>
+            <a:prstGeom prst="rect">
+              <a:avLst/>
+            </a:prstGeom>
+            <a:noFill/>
+          </p:spPr>
+          <p:txBody>
+            <a:bodyPr lIns="0" rIns="0" tIns="0" bIns="0" anchorCtr="1" anchor="ctr" wrap="none"/>
+            <a:lstStyle/>
+            <a:p>
+              <a:pPr algn="l" marL="0" marR="0" indent="0">
+                <a:spcBef>
+                  <a:spcPts val="0"/>
+                </a:spcBef>
+                <a:spcAft>
+                  <a:spcPts val="0"/>
+                </a:spcAft>
+              </a:pPr>
+              <a:r>
+                <a:rPr sz="1066" i="0" b="0">
+                  <a:solidFill>
+                    <a:srgbClr val="000000">
+                      <a:alpha val="100000"/>
+                    </a:srgbClr>
+                  </a:solidFill>
+                  <a:latin typeface="Arial"/>
+                  <a:cs typeface="Arial"/>
+                </a:rPr>
+                <a:t>5/11</a:t>
+              </a:r>
+            </a:p>
+          </p:txBody>
+        </p:sp>
+        <p:sp>
+          <p:nvSpPr>
+            <p:cNvPr id="66" name="tx66"/>
+            <p:cNvSpPr/>
+            <p:nvPr/>
+          </p:nvSpPr>
+          <p:spPr>
+            <a:xfrm>
+              <a:off x="3595077" y="2806234"/>
+              <a:ext cx="338602" cy="96926"/>
+            </a:xfrm>
+            <a:prstGeom prst="rect">
+              <a:avLst/>
+            </a:prstGeom>
+            <a:noFill/>
+          </p:spPr>
+          <p:txBody>
+            <a:bodyPr lIns="0" rIns="0" tIns="0" bIns="0" anchorCtr="1" anchor="ctr" wrap="none"/>
+            <a:lstStyle/>
+            <a:p>
+              <a:pPr algn="l" marL="0" marR="0" indent="0">
+                <a:spcBef>
+                  <a:spcPts val="0"/>
+                </a:spcBef>
+                <a:spcAft>
+                  <a:spcPts val="0"/>
+                </a:spcAft>
+              </a:pPr>
+              <a:r>
+                <a:rPr sz="1066" i="0" b="0">
+                  <a:solidFill>
+                    <a:srgbClr val="000000">
+                      <a:alpha val="100000"/>
+                    </a:srgbClr>
+                  </a:solidFill>
+                  <a:latin typeface="Arial"/>
+                  <a:cs typeface="Arial"/>
+                </a:rPr>
+                <a:t>23/48</a:t>
+              </a:r>
+            </a:p>
+          </p:txBody>
+        </p:sp>
+        <p:sp>
+          <p:nvSpPr>
+            <p:cNvPr id="67" name="tx67"/>
+            <p:cNvSpPr/>
+            <p:nvPr/>
+          </p:nvSpPr>
+          <p:spPr>
+            <a:xfrm>
+              <a:off x="4296883" y="2806234"/>
+              <a:ext cx="338602" cy="96926"/>
+            </a:xfrm>
+            <a:prstGeom prst="rect">
+              <a:avLst/>
+            </a:prstGeom>
+            <a:noFill/>
+          </p:spPr>
+          <p:txBody>
+            <a:bodyPr lIns="0" rIns="0" tIns="0" bIns="0" anchorCtr="1" anchor="ctr" wrap="none"/>
+            <a:lstStyle/>
+            <a:p>
+              <a:pPr algn="l" marL="0" marR="0" indent="0">
+                <a:spcBef>
+                  <a:spcPts val="0"/>
+                </a:spcBef>
+                <a:spcAft>
+                  <a:spcPts val="0"/>
+                </a:spcAft>
+              </a:pPr>
+              <a:r>
+                <a:rPr sz="1066" i="0" b="0">
+                  <a:solidFill>
+                    <a:srgbClr val="000000">
+                      <a:alpha val="100000"/>
+                    </a:srgbClr>
+                  </a:solidFill>
+                  <a:latin typeface="Arial"/>
+                  <a:cs typeface="Arial"/>
+                </a:rPr>
+                <a:t>15/31</a:t>
+              </a:r>
+            </a:p>
+          </p:txBody>
+        </p:sp>
+        <p:sp>
+          <p:nvSpPr>
+            <p:cNvPr id="68" name="tx68"/>
+            <p:cNvSpPr/>
+            <p:nvPr/>
+          </p:nvSpPr>
+          <p:spPr>
+            <a:xfrm>
+              <a:off x="5036317" y="2806234"/>
+              <a:ext cx="263347" cy="96926"/>
+            </a:xfrm>
+            <a:prstGeom prst="rect">
+              <a:avLst/>
+            </a:prstGeom>
+            <a:noFill/>
+          </p:spPr>
+          <p:txBody>
+            <a:bodyPr lIns="0" rIns="0" tIns="0" bIns="0" anchorCtr="1" anchor="ctr" wrap="none"/>
+            <a:lstStyle/>
+            <a:p>
+              <a:pPr algn="l" marL="0" marR="0" indent="0">
+                <a:spcBef>
+                  <a:spcPts val="0"/>
+                </a:spcBef>
+                <a:spcAft>
+                  <a:spcPts val="0"/>
+                </a:spcAft>
+              </a:pPr>
+              <a:r>
+                <a:rPr sz="1066" i="0" b="0">
+                  <a:solidFill>
+                    <a:srgbClr val="000000">
+                      <a:alpha val="100000"/>
+                    </a:srgbClr>
+                  </a:solidFill>
+                  <a:latin typeface="Arial"/>
+                  <a:cs typeface="Arial"/>
+                </a:rPr>
+                <a:t>8/21</a:t>
+              </a:r>
+            </a:p>
+          </p:txBody>
+        </p:sp>
+        <p:sp>
+          <p:nvSpPr>
+            <p:cNvPr id="69" name="tx69"/>
+            <p:cNvSpPr/>
+            <p:nvPr/>
+          </p:nvSpPr>
+          <p:spPr>
+            <a:xfrm>
+              <a:off x="1452032" y="2104428"/>
+              <a:ext cx="413857" cy="96926"/>
+            </a:xfrm>
+            <a:prstGeom prst="rect">
+              <a:avLst/>
+            </a:prstGeom>
+            <a:noFill/>
+          </p:spPr>
+          <p:txBody>
+            <a:bodyPr lIns="0" rIns="0" tIns="0" bIns="0" anchorCtr="1" anchor="ctr" wrap="none"/>
+            <a:lstStyle/>
+            <a:p>
+              <a:pPr algn="l" marL="0" marR="0" indent="0">
+                <a:spcBef>
+                  <a:spcPts val="0"/>
+                </a:spcBef>
+                <a:spcAft>
+                  <a:spcPts val="0"/>
+                </a:spcAft>
+              </a:pPr>
+              <a:r>
+                <a:rPr sz="1066" i="0" b="0">
+                  <a:solidFill>
+                    <a:srgbClr val="000000">
+                      <a:alpha val="100000"/>
+                    </a:srgbClr>
+                  </a:solidFill>
+                  <a:latin typeface="Arial"/>
+                  <a:cs typeface="Arial"/>
+                </a:rPr>
+                <a:t>56/218</a:t>
+              </a:r>
+            </a:p>
+          </p:txBody>
+        </p:sp>
+        <p:sp>
+          <p:nvSpPr>
+            <p:cNvPr id="70" name="tx70"/>
+            <p:cNvSpPr/>
+            <p:nvPr/>
+          </p:nvSpPr>
+          <p:spPr>
+            <a:xfrm>
+              <a:off x="2153838" y="2104428"/>
+              <a:ext cx="413857" cy="96926"/>
+            </a:xfrm>
+            <a:prstGeom prst="rect">
+              <a:avLst/>
+            </a:prstGeom>
+            <a:noFill/>
+          </p:spPr>
+          <p:txBody>
+            <a:bodyPr lIns="0" rIns="0" tIns="0" bIns="0" anchorCtr="1" anchor="ctr" wrap="none"/>
+            <a:lstStyle/>
+            <a:p>
+              <a:pPr algn="l" marL="0" marR="0" indent="0">
+                <a:spcBef>
+                  <a:spcPts val="0"/>
+                </a:spcBef>
+                <a:spcAft>
+                  <a:spcPts val="0"/>
+                </a:spcAft>
+              </a:pPr>
+              <a:r>
+                <a:rPr sz="1066" i="0" b="0">
+                  <a:solidFill>
+                    <a:srgbClr val="000000">
+                      <a:alpha val="100000"/>
+                    </a:srgbClr>
+                  </a:solidFill>
+                  <a:latin typeface="Arial"/>
+                  <a:cs typeface="Arial"/>
+                </a:rPr>
+                <a:t>55/139</a:t>
+              </a:r>
+            </a:p>
+          </p:txBody>
+        </p:sp>
+        <p:sp>
+          <p:nvSpPr>
+            <p:cNvPr id="71" name="tx71"/>
+            <p:cNvSpPr/>
+            <p:nvPr/>
+          </p:nvSpPr>
+          <p:spPr>
+            <a:xfrm>
+              <a:off x="2893271" y="2104428"/>
+              <a:ext cx="338602" cy="96926"/>
+            </a:xfrm>
+            <a:prstGeom prst="rect">
+              <a:avLst/>
+            </a:prstGeom>
+            <a:noFill/>
+          </p:spPr>
+          <p:txBody>
+            <a:bodyPr lIns="0" rIns="0" tIns="0" bIns="0" anchorCtr="1" anchor="ctr" wrap="none"/>
+            <a:lstStyle/>
+            <a:p>
+              <a:pPr algn="l" marL="0" marR="0" indent="0">
+                <a:spcBef>
+                  <a:spcPts val="0"/>
+                </a:spcBef>
+                <a:spcAft>
+                  <a:spcPts val="0"/>
+                </a:spcAft>
+              </a:pPr>
+              <a:r>
+                <a:rPr sz="1066" i="0" b="0">
+                  <a:solidFill>
+                    <a:srgbClr val="000000">
+                      <a:alpha val="100000"/>
+                    </a:srgbClr>
+                  </a:solidFill>
+                  <a:latin typeface="Arial"/>
+                  <a:cs typeface="Arial"/>
+                </a:rPr>
+                <a:t>18/98</a:t>
+              </a:r>
+            </a:p>
+          </p:txBody>
+        </p:sp>
+        <p:sp>
+          <p:nvSpPr>
+            <p:cNvPr id="72" name="tx72"/>
+            <p:cNvSpPr/>
+            <p:nvPr/>
+          </p:nvSpPr>
+          <p:spPr>
+            <a:xfrm>
+              <a:off x="3557450" y="2104428"/>
+              <a:ext cx="413857" cy="96926"/>
+            </a:xfrm>
+            <a:prstGeom prst="rect">
+              <a:avLst/>
+            </a:prstGeom>
+            <a:noFill/>
+          </p:spPr>
+          <p:txBody>
+            <a:bodyPr lIns="0" rIns="0" tIns="0" bIns="0" anchorCtr="1" anchor="ctr" wrap="none"/>
+            <a:lstStyle/>
+            <a:p>
+              <a:pPr algn="l" marL="0" marR="0" indent="0">
+                <a:spcBef>
+                  <a:spcPts val="0"/>
+                </a:spcBef>
+                <a:spcAft>
+                  <a:spcPts val="0"/>
+                </a:spcAft>
+              </a:pPr>
+              <a:r>
+                <a:rPr sz="1066" i="0" b="0">
+                  <a:solidFill>
+                    <a:srgbClr val="000000">
+                      <a:alpha val="100000"/>
+                    </a:srgbClr>
+                  </a:solidFill>
+                  <a:latin typeface="Arial"/>
+                  <a:cs typeface="Arial"/>
+                </a:rPr>
+                <a:t>73/394</a:t>
+              </a:r>
+            </a:p>
+          </p:txBody>
+        </p:sp>
+        <p:sp>
+          <p:nvSpPr>
+            <p:cNvPr id="73" name="tx73"/>
+            <p:cNvSpPr/>
+            <p:nvPr/>
+          </p:nvSpPr>
+          <p:spPr>
+            <a:xfrm>
+              <a:off x="4259256" y="2104428"/>
+              <a:ext cx="413857" cy="96926"/>
+            </a:xfrm>
+            <a:prstGeom prst="rect">
+              <a:avLst/>
+            </a:prstGeom>
+            <a:noFill/>
+          </p:spPr>
+          <p:txBody>
+            <a:bodyPr lIns="0" rIns="0" tIns="0" bIns="0" anchorCtr="1" anchor="ctr" wrap="none"/>
+            <a:lstStyle/>
+            <a:p>
+              <a:pPr algn="l" marL="0" marR="0" indent="0">
+                <a:spcBef>
+                  <a:spcPts val="0"/>
+                </a:spcBef>
+                <a:spcAft>
+                  <a:spcPts val="0"/>
+                </a:spcAft>
+              </a:pPr>
+              <a:r>
+                <a:rPr sz="1066" i="0" b="0">
+                  <a:solidFill>
+                    <a:srgbClr val="000000">
+                      <a:alpha val="100000"/>
+                    </a:srgbClr>
+                  </a:solidFill>
+                  <a:latin typeface="Arial"/>
+                  <a:cs typeface="Arial"/>
+                </a:rPr>
+                <a:t>73/185</a:t>
+              </a:r>
+            </a:p>
+          </p:txBody>
+        </p:sp>
+        <p:sp>
+          <p:nvSpPr>
+            <p:cNvPr id="74" name="tx74"/>
+            <p:cNvSpPr/>
+            <p:nvPr/>
+          </p:nvSpPr>
+          <p:spPr>
+            <a:xfrm>
+              <a:off x="4961061" y="2037759"/>
+              <a:ext cx="413857" cy="96926"/>
+            </a:xfrm>
+            <a:prstGeom prst="rect">
+              <a:avLst/>
+            </a:prstGeom>
+            <a:noFill/>
+          </p:spPr>
+          <p:txBody>
+            <a:bodyPr lIns="0" rIns="0" tIns="0" bIns="0" anchorCtr="1" anchor="ctr" wrap="none"/>
+            <a:lstStyle/>
+            <a:p>
+              <a:pPr algn="l" marL="0" marR="0" indent="0">
+                <a:spcBef>
+                  <a:spcPts val="0"/>
+                </a:spcBef>
+                <a:spcAft>
+                  <a:spcPts val="0"/>
+                </a:spcAft>
+              </a:pPr>
+              <a:r>
+                <a:rPr sz="1066" i="0" b="0">
+                  <a:solidFill>
+                    <a:srgbClr val="000000">
+                      <a:alpha val="100000"/>
+                    </a:srgbClr>
+                  </a:solidFill>
+                  <a:latin typeface="Arial"/>
+                  <a:cs typeface="Arial"/>
+                </a:rPr>
+                <a:t>81/136</a:t>
+              </a:r>
+            </a:p>
+          </p:txBody>
+        </p:sp>
+        <p:sp>
+          <p:nvSpPr>
+            <p:cNvPr id="75" name="tx75"/>
+            <p:cNvSpPr/>
+            <p:nvPr/>
+          </p:nvSpPr>
+          <p:spPr>
+            <a:xfrm>
+              <a:off x="5115321" y="2171098"/>
+              <a:ext cx="105338" cy="96926"/>
+            </a:xfrm>
+            <a:prstGeom prst="rect">
+              <a:avLst/>
+            </a:prstGeom>
+            <a:noFill/>
+          </p:spPr>
+          <p:txBody>
+            <a:bodyPr lIns="0" rIns="0" tIns="0" bIns="0" anchorCtr="1" anchor="ctr" wrap="none"/>
+            <a:lstStyle/>
+            <a:p>
+              <a:pPr algn="l" marL="0" marR="0" indent="0">
+                <a:spcBef>
+                  <a:spcPts val="0"/>
+                </a:spcBef>
+                <a:spcAft>
+                  <a:spcPts val="0"/>
+                </a:spcAft>
+              </a:pPr>
+              <a:r>
+                <a:rPr sz="1066" i="0" b="0">
+                  <a:solidFill>
+                    <a:srgbClr val="000000">
+                      <a:alpha val="100000"/>
+                    </a:srgbClr>
+                  </a:solidFill>
+                  <a:latin typeface="Arial"/>
+                  <a:cs typeface="Arial"/>
+                </a:rPr>
+                <a:t>**</a:t>
+              </a:r>
+            </a:p>
+          </p:txBody>
+        </p:sp>
+        <p:sp>
+          <p:nvSpPr>
+            <p:cNvPr id="76" name="tx76"/>
+            <p:cNvSpPr/>
+            <p:nvPr/>
+          </p:nvSpPr>
+          <p:spPr>
+            <a:xfrm>
+              <a:off x="1452032" y="1335953"/>
+              <a:ext cx="413857" cy="96926"/>
+            </a:xfrm>
+            <a:prstGeom prst="rect">
+              <a:avLst/>
+            </a:prstGeom>
+            <a:noFill/>
+          </p:spPr>
+          <p:txBody>
+            <a:bodyPr lIns="0" rIns="0" tIns="0" bIns="0" anchorCtr="1" anchor="ctr" wrap="none"/>
+            <a:lstStyle/>
+            <a:p>
+              <a:pPr algn="l" marL="0" marR="0" indent="0">
+                <a:spcBef>
+                  <a:spcPts val="0"/>
+                </a:spcBef>
+                <a:spcAft>
+                  <a:spcPts val="0"/>
+                </a:spcAft>
+              </a:pPr>
+              <a:r>
+                <a:rPr sz="1066" i="0" b="0">
+                  <a:solidFill>
+                    <a:srgbClr val="000000">
+                      <a:alpha val="100000"/>
+                    </a:srgbClr>
+                  </a:solidFill>
+                  <a:latin typeface="Arial"/>
+                  <a:cs typeface="Arial"/>
+                </a:rPr>
+                <a:t>95/146</a:t>
+              </a:r>
+            </a:p>
+          </p:txBody>
+        </p:sp>
+        <p:sp>
+          <p:nvSpPr>
+            <p:cNvPr id="77" name="tx77"/>
+            <p:cNvSpPr/>
+            <p:nvPr/>
+          </p:nvSpPr>
+          <p:spPr>
+            <a:xfrm>
+              <a:off x="1632626" y="1469292"/>
+              <a:ext cx="52669" cy="96926"/>
+            </a:xfrm>
+            <a:prstGeom prst="rect">
+              <a:avLst/>
+            </a:prstGeom>
+            <a:noFill/>
+          </p:spPr>
+          <p:txBody>
+            <a:bodyPr lIns="0" rIns="0" tIns="0" bIns="0" anchorCtr="1" anchor="ctr" wrap="none"/>
+            <a:lstStyle/>
+            <a:p>
+              <a:pPr algn="l" marL="0" marR="0" indent="0">
+                <a:spcBef>
+                  <a:spcPts val="0"/>
+                </a:spcBef>
+                <a:spcAft>
+                  <a:spcPts val="0"/>
+                </a:spcAft>
+              </a:pPr>
+              <a:r>
+                <a:rPr sz="1066" i="0" b="0">
                   <a:solidFill>
                     <a:srgbClr val="000000">
                       <a:alpha val="100000"/>
@@ -4050,14 +5125,14 @@
         </p:sp>
         <p:sp>
           <p:nvSpPr>
-            <p:cNvPr id="53" name="tx53"/>
-            <p:cNvSpPr/>
-            <p:nvPr/>
-          </p:nvSpPr>
-          <p:spPr>
-            <a:xfrm>
-              <a:off x="4311362" y="4192417"/>
-              <a:ext cx="284286" cy="81381"/>
+            <p:cNvPr id="78" name="tx78"/>
+            <p:cNvSpPr/>
+            <p:nvPr/>
+          </p:nvSpPr>
+          <p:spPr>
+            <a:xfrm>
+              <a:off x="2153838" y="1402622"/>
+              <a:ext cx="413857" cy="96926"/>
             </a:xfrm>
             <a:prstGeom prst="rect">
               <a:avLst/>
@@ -4077,1039 +5152,7 @@
                 </a:spcAft>
               </a:pPr>
               <a:r>
-                <a:rPr sz="896" i="0" b="0">
-                  <a:solidFill>
-                    <a:srgbClr val="000000">
-                      <a:alpha val="100000"/>
-                    </a:srgbClr>
-                  </a:solidFill>
-                  <a:latin typeface="Arial"/>
-                  <a:cs typeface="Arial"/>
-                </a:rPr>
-                <a:t>67/78</a:t>
-              </a:r>
-            </a:p>
-          </p:txBody>
-        </p:sp>
-        <p:sp>
-          <p:nvSpPr>
-            <p:cNvPr id="54" name="tx54"/>
-            <p:cNvSpPr/>
-            <p:nvPr/>
-          </p:nvSpPr>
-          <p:spPr>
-            <a:xfrm>
-              <a:off x="4431377" y="4304421"/>
-              <a:ext cx="44256" cy="81381"/>
-            </a:xfrm>
-            <a:prstGeom prst="rect">
-              <a:avLst/>
-            </a:prstGeom>
-            <a:noFill/>
-          </p:spPr>
-          <p:txBody>
-            <a:bodyPr lIns="0" rIns="0" tIns="0" bIns="0" anchorCtr="1" anchor="ctr" wrap="none"/>
-            <a:lstStyle/>
-            <a:p>
-              <a:pPr algn="l" marL="0" marR="0" indent="0">
-                <a:spcBef>
-                  <a:spcPts val="0"/>
-                </a:spcBef>
-                <a:spcAft>
-                  <a:spcPts val="0"/>
-                </a:spcAft>
-              </a:pPr>
-              <a:r>
-                <a:rPr sz="896" i="0" b="0">
-                  <a:solidFill>
-                    <a:srgbClr val="000000">
-                      <a:alpha val="100000"/>
-                    </a:srgbClr>
-                  </a:solidFill>
-                  <a:latin typeface="Arial"/>
-                  <a:cs typeface="Arial"/>
-                </a:rPr>
-                <a:t>*</a:t>
-              </a:r>
-            </a:p>
-          </p:txBody>
-        </p:sp>
-        <p:sp>
-          <p:nvSpPr>
-            <p:cNvPr id="55" name="tx55"/>
-            <p:cNvSpPr/>
-            <p:nvPr/>
-          </p:nvSpPr>
-          <p:spPr>
-            <a:xfrm>
-              <a:off x="5019863" y="4248419"/>
-              <a:ext cx="284286" cy="81381"/>
-            </a:xfrm>
-            <a:prstGeom prst="rect">
-              <a:avLst/>
-            </a:prstGeom>
-            <a:noFill/>
-          </p:spPr>
-          <p:txBody>
-            <a:bodyPr lIns="0" rIns="0" tIns="0" bIns="0" anchorCtr="1" anchor="ctr" wrap="none"/>
-            <a:lstStyle/>
-            <a:p>
-              <a:pPr algn="l" marL="0" marR="0" indent="0">
-                <a:spcBef>
-                  <a:spcPts val="0"/>
-                </a:spcBef>
-                <a:spcAft>
-                  <a:spcPts val="0"/>
-                </a:spcAft>
-              </a:pPr>
-              <a:r>
-                <a:rPr sz="896" i="0" b="0">
-                  <a:solidFill>
-                    <a:srgbClr val="000000">
-                      <a:alpha val="100000"/>
-                    </a:srgbClr>
-                  </a:solidFill>
-                  <a:latin typeface="Arial"/>
-                  <a:cs typeface="Arial"/>
-                </a:rPr>
-                <a:t>20/40</a:t>
-              </a:r>
-            </a:p>
-          </p:txBody>
-        </p:sp>
-        <p:sp>
-          <p:nvSpPr>
-            <p:cNvPr id="56" name="tx56"/>
-            <p:cNvSpPr/>
-            <p:nvPr/>
-          </p:nvSpPr>
-          <p:spPr>
-            <a:xfrm>
-              <a:off x="1477355" y="3539918"/>
-              <a:ext cx="284286" cy="81381"/>
-            </a:xfrm>
-            <a:prstGeom prst="rect">
-              <a:avLst/>
-            </a:prstGeom>
-            <a:noFill/>
-          </p:spPr>
-          <p:txBody>
-            <a:bodyPr lIns="0" rIns="0" tIns="0" bIns="0" anchorCtr="1" anchor="ctr" wrap="none"/>
-            <a:lstStyle/>
-            <a:p>
-              <a:pPr algn="l" marL="0" marR="0" indent="0">
-                <a:spcBef>
-                  <a:spcPts val="0"/>
-                </a:spcBef>
-                <a:spcAft>
-                  <a:spcPts val="0"/>
-                </a:spcAft>
-              </a:pPr>
-              <a:r>
-                <a:rPr sz="896" i="0" b="0">
-                  <a:solidFill>
-                    <a:srgbClr val="000000">
-                      <a:alpha val="100000"/>
-                    </a:srgbClr>
-                  </a:solidFill>
-                  <a:latin typeface="Arial"/>
-                  <a:cs typeface="Arial"/>
-                </a:rPr>
-                <a:t>16/54</a:t>
-              </a:r>
-            </a:p>
-          </p:txBody>
-        </p:sp>
-        <p:sp>
-          <p:nvSpPr>
-            <p:cNvPr id="57" name="tx57"/>
-            <p:cNvSpPr/>
-            <p:nvPr/>
-          </p:nvSpPr>
-          <p:spPr>
-            <a:xfrm>
-              <a:off x="2185856" y="3539918"/>
-              <a:ext cx="284286" cy="81381"/>
-            </a:xfrm>
-            <a:prstGeom prst="rect">
-              <a:avLst/>
-            </a:prstGeom>
-            <a:noFill/>
-          </p:spPr>
-          <p:txBody>
-            <a:bodyPr lIns="0" rIns="0" tIns="0" bIns="0" anchorCtr="1" anchor="ctr" wrap="none"/>
-            <a:lstStyle/>
-            <a:p>
-              <a:pPr algn="l" marL="0" marR="0" indent="0">
-                <a:spcBef>
-                  <a:spcPts val="0"/>
-                </a:spcBef>
-                <a:spcAft>
-                  <a:spcPts val="0"/>
-                </a:spcAft>
-              </a:pPr>
-              <a:r>
-                <a:rPr sz="896" i="0" b="0">
-                  <a:solidFill>
-                    <a:srgbClr val="000000">
-                      <a:alpha val="100000"/>
-                    </a:srgbClr>
-                  </a:solidFill>
-                  <a:latin typeface="Arial"/>
-                  <a:cs typeface="Arial"/>
-                </a:rPr>
-                <a:t>22/36</a:t>
-              </a:r>
-            </a:p>
-          </p:txBody>
-        </p:sp>
-        <p:sp>
-          <p:nvSpPr>
-            <p:cNvPr id="58" name="tx58"/>
-            <p:cNvSpPr/>
-            <p:nvPr/>
-          </p:nvSpPr>
-          <p:spPr>
-            <a:xfrm>
-              <a:off x="2894358" y="3539918"/>
-              <a:ext cx="284286" cy="81381"/>
-            </a:xfrm>
-            <a:prstGeom prst="rect">
-              <a:avLst/>
-            </a:prstGeom>
-            <a:noFill/>
-          </p:spPr>
-          <p:txBody>
-            <a:bodyPr lIns="0" rIns="0" tIns="0" bIns="0" anchorCtr="1" anchor="ctr" wrap="none"/>
-            <a:lstStyle/>
-            <a:p>
-              <a:pPr algn="l" marL="0" marR="0" indent="0">
-                <a:spcBef>
-                  <a:spcPts val="0"/>
-                </a:spcBef>
-                <a:spcAft>
-                  <a:spcPts val="0"/>
-                </a:spcAft>
-              </a:pPr>
-              <a:r>
-                <a:rPr sz="896" i="0" b="0">
-                  <a:solidFill>
-                    <a:srgbClr val="000000">
-                      <a:alpha val="100000"/>
-                    </a:srgbClr>
-                  </a:solidFill>
-                  <a:latin typeface="Arial"/>
-                  <a:cs typeface="Arial"/>
-                </a:rPr>
-                <a:t>12/18</a:t>
-              </a:r>
-            </a:p>
-          </p:txBody>
-        </p:sp>
-        <p:sp>
-          <p:nvSpPr>
-            <p:cNvPr id="59" name="tx59"/>
-            <p:cNvSpPr/>
-            <p:nvPr/>
-          </p:nvSpPr>
-          <p:spPr>
-            <a:xfrm>
-              <a:off x="3602860" y="3539918"/>
-              <a:ext cx="284286" cy="81381"/>
-            </a:xfrm>
-            <a:prstGeom prst="rect">
-              <a:avLst/>
-            </a:prstGeom>
-            <a:noFill/>
-          </p:spPr>
-          <p:txBody>
-            <a:bodyPr lIns="0" rIns="0" tIns="0" bIns="0" anchorCtr="1" anchor="ctr" wrap="none"/>
-            <a:lstStyle/>
-            <a:p>
-              <a:pPr algn="l" marL="0" marR="0" indent="0">
-                <a:spcBef>
-                  <a:spcPts val="0"/>
-                </a:spcBef>
-                <a:spcAft>
-                  <a:spcPts val="0"/>
-                </a:spcAft>
-              </a:pPr>
-              <a:r>
-                <a:rPr sz="896" i="0" b="0">
-                  <a:solidFill>
-                    <a:srgbClr val="000000">
-                      <a:alpha val="100000"/>
-                    </a:srgbClr>
-                  </a:solidFill>
-                  <a:latin typeface="Arial"/>
-                  <a:cs typeface="Arial"/>
-                </a:rPr>
-                <a:t>36/84</a:t>
-              </a:r>
-            </a:p>
-          </p:txBody>
-        </p:sp>
-        <p:sp>
-          <p:nvSpPr>
-            <p:cNvPr id="60" name="tx60"/>
-            <p:cNvSpPr/>
-            <p:nvPr/>
-          </p:nvSpPr>
-          <p:spPr>
-            <a:xfrm>
-              <a:off x="4311362" y="3539918"/>
-              <a:ext cx="284286" cy="81381"/>
-            </a:xfrm>
-            <a:prstGeom prst="rect">
-              <a:avLst/>
-            </a:prstGeom>
-            <a:noFill/>
-          </p:spPr>
-          <p:txBody>
-            <a:bodyPr lIns="0" rIns="0" tIns="0" bIns="0" anchorCtr="1" anchor="ctr" wrap="none"/>
-            <a:lstStyle/>
-            <a:p>
-              <a:pPr algn="l" marL="0" marR="0" indent="0">
-                <a:spcBef>
-                  <a:spcPts val="0"/>
-                </a:spcBef>
-                <a:spcAft>
-                  <a:spcPts val="0"/>
-                </a:spcAft>
-              </a:pPr>
-              <a:r>
-                <a:rPr sz="896" i="0" b="0">
-                  <a:solidFill>
-                    <a:srgbClr val="000000">
-                      <a:alpha val="100000"/>
-                    </a:srgbClr>
-                  </a:solidFill>
-                  <a:latin typeface="Arial"/>
-                  <a:cs typeface="Arial"/>
-                </a:rPr>
-                <a:t>20/52</a:t>
-              </a:r>
-            </a:p>
-          </p:txBody>
-        </p:sp>
-        <p:sp>
-          <p:nvSpPr>
-            <p:cNvPr id="61" name="tx61"/>
-            <p:cNvSpPr/>
-            <p:nvPr/>
-          </p:nvSpPr>
-          <p:spPr>
-            <a:xfrm>
-              <a:off x="5019863" y="3539918"/>
-              <a:ext cx="284286" cy="81381"/>
-            </a:xfrm>
-            <a:prstGeom prst="rect">
-              <a:avLst/>
-            </a:prstGeom>
-            <a:noFill/>
-          </p:spPr>
-          <p:txBody>
-            <a:bodyPr lIns="0" rIns="0" tIns="0" bIns="0" anchorCtr="1" anchor="ctr" wrap="none"/>
-            <a:lstStyle/>
-            <a:p>
-              <a:pPr algn="l" marL="0" marR="0" indent="0">
-                <a:spcBef>
-                  <a:spcPts val="0"/>
-                </a:spcBef>
-                <a:spcAft>
-                  <a:spcPts val="0"/>
-                </a:spcAft>
-              </a:pPr>
-              <a:r>
-                <a:rPr sz="896" i="0" b="0">
-                  <a:solidFill>
-                    <a:srgbClr val="000000">
-                      <a:alpha val="100000"/>
-                    </a:srgbClr>
-                  </a:solidFill>
-                  <a:latin typeface="Arial"/>
-                  <a:cs typeface="Arial"/>
-                </a:rPr>
-                <a:t>15/30</a:t>
-              </a:r>
-            </a:p>
-          </p:txBody>
-        </p:sp>
-        <p:sp>
-          <p:nvSpPr>
-            <p:cNvPr id="62" name="tx62"/>
-            <p:cNvSpPr/>
-            <p:nvPr/>
-          </p:nvSpPr>
-          <p:spPr>
-            <a:xfrm>
-              <a:off x="1481561" y="2831416"/>
-              <a:ext cx="275874" cy="81381"/>
-            </a:xfrm>
-            <a:prstGeom prst="rect">
-              <a:avLst/>
-            </a:prstGeom>
-            <a:noFill/>
-          </p:spPr>
-          <p:txBody>
-            <a:bodyPr lIns="0" rIns="0" tIns="0" bIns="0" anchorCtr="1" anchor="ctr" wrap="none"/>
-            <a:lstStyle/>
-            <a:p>
-              <a:pPr algn="l" marL="0" marR="0" indent="0">
-                <a:spcBef>
-                  <a:spcPts val="0"/>
-                </a:spcBef>
-                <a:spcAft>
-                  <a:spcPts val="0"/>
-                </a:spcAft>
-              </a:pPr>
-              <a:r>
-                <a:rPr sz="896" i="0" b="0">
-                  <a:solidFill>
-                    <a:srgbClr val="000000">
-                      <a:alpha val="100000"/>
-                    </a:srgbClr>
-                  </a:solidFill>
-                  <a:latin typeface="Arial"/>
-                  <a:cs typeface="Arial"/>
-                </a:rPr>
-                <a:t>11/27</a:t>
-              </a:r>
-            </a:p>
-          </p:txBody>
-        </p:sp>
-        <p:sp>
-          <p:nvSpPr>
-            <p:cNvPr id="63" name="tx63"/>
-            <p:cNvSpPr/>
-            <p:nvPr/>
-          </p:nvSpPr>
-          <p:spPr>
-            <a:xfrm>
-              <a:off x="2185856" y="2831416"/>
-              <a:ext cx="284286" cy="81381"/>
-            </a:xfrm>
-            <a:prstGeom prst="rect">
-              <a:avLst/>
-            </a:prstGeom>
-            <a:noFill/>
-          </p:spPr>
-          <p:txBody>
-            <a:bodyPr lIns="0" rIns="0" tIns="0" bIns="0" anchorCtr="1" anchor="ctr" wrap="none"/>
-            <a:lstStyle/>
-            <a:p>
-              <a:pPr algn="l" marL="0" marR="0" indent="0">
-                <a:spcBef>
-                  <a:spcPts val="0"/>
-                </a:spcBef>
-                <a:spcAft>
-                  <a:spcPts val="0"/>
-                </a:spcAft>
-              </a:pPr>
-              <a:r>
-                <a:rPr sz="896" i="0" b="0">
-                  <a:solidFill>
-                    <a:srgbClr val="000000">
-                      <a:alpha val="100000"/>
-                    </a:srgbClr>
-                  </a:solidFill>
-                  <a:latin typeface="Arial"/>
-                  <a:cs typeface="Arial"/>
-                </a:rPr>
-                <a:t>12/18</a:t>
-              </a:r>
-            </a:p>
-          </p:txBody>
-        </p:sp>
-        <p:sp>
-          <p:nvSpPr>
-            <p:cNvPr id="64" name="tx64"/>
-            <p:cNvSpPr/>
-            <p:nvPr/>
-          </p:nvSpPr>
-          <p:spPr>
-            <a:xfrm>
-              <a:off x="2930157" y="2831416"/>
-              <a:ext cx="212689" cy="81381"/>
-            </a:xfrm>
-            <a:prstGeom prst="rect">
-              <a:avLst/>
-            </a:prstGeom>
-            <a:noFill/>
-          </p:spPr>
-          <p:txBody>
-            <a:bodyPr lIns="0" rIns="0" tIns="0" bIns="0" anchorCtr="1" anchor="ctr" wrap="none"/>
-            <a:lstStyle/>
-            <a:p>
-              <a:pPr algn="l" marL="0" marR="0" indent="0">
-                <a:spcBef>
-                  <a:spcPts val="0"/>
-                </a:spcBef>
-                <a:spcAft>
-                  <a:spcPts val="0"/>
-                </a:spcAft>
-              </a:pPr>
-              <a:r>
-                <a:rPr sz="896" i="0" b="0">
-                  <a:solidFill>
-                    <a:srgbClr val="000000">
-                      <a:alpha val="100000"/>
-                    </a:srgbClr>
-                  </a:solidFill>
-                  <a:latin typeface="Arial"/>
-                  <a:cs typeface="Arial"/>
-                </a:rPr>
-                <a:t>5/11</a:t>
-              </a:r>
-            </a:p>
-          </p:txBody>
-        </p:sp>
-        <p:sp>
-          <p:nvSpPr>
-            <p:cNvPr id="65" name="tx65"/>
-            <p:cNvSpPr/>
-            <p:nvPr/>
-          </p:nvSpPr>
-          <p:spPr>
-            <a:xfrm>
-              <a:off x="3602860" y="2831416"/>
-              <a:ext cx="284286" cy="81381"/>
-            </a:xfrm>
-            <a:prstGeom prst="rect">
-              <a:avLst/>
-            </a:prstGeom>
-            <a:noFill/>
-          </p:spPr>
-          <p:txBody>
-            <a:bodyPr lIns="0" rIns="0" tIns="0" bIns="0" anchorCtr="1" anchor="ctr" wrap="none"/>
-            <a:lstStyle/>
-            <a:p>
-              <a:pPr algn="l" marL="0" marR="0" indent="0">
-                <a:spcBef>
-                  <a:spcPts val="0"/>
-                </a:spcBef>
-                <a:spcAft>
-                  <a:spcPts val="0"/>
-                </a:spcAft>
-              </a:pPr>
-              <a:r>
-                <a:rPr sz="896" i="0" b="0">
-                  <a:solidFill>
-                    <a:srgbClr val="000000">
-                      <a:alpha val="100000"/>
-                    </a:srgbClr>
-                  </a:solidFill>
-                  <a:latin typeface="Arial"/>
-                  <a:cs typeface="Arial"/>
-                </a:rPr>
-                <a:t>23/48</a:t>
-              </a:r>
-            </a:p>
-          </p:txBody>
-        </p:sp>
-        <p:sp>
-          <p:nvSpPr>
-            <p:cNvPr id="66" name="tx66"/>
-            <p:cNvSpPr/>
-            <p:nvPr/>
-          </p:nvSpPr>
-          <p:spPr>
-            <a:xfrm>
-              <a:off x="4311362" y="2831416"/>
-              <a:ext cx="284286" cy="81381"/>
-            </a:xfrm>
-            <a:prstGeom prst="rect">
-              <a:avLst/>
-            </a:prstGeom>
-            <a:noFill/>
-          </p:spPr>
-          <p:txBody>
-            <a:bodyPr lIns="0" rIns="0" tIns="0" bIns="0" anchorCtr="1" anchor="ctr" wrap="none"/>
-            <a:lstStyle/>
-            <a:p>
-              <a:pPr algn="l" marL="0" marR="0" indent="0">
-                <a:spcBef>
-                  <a:spcPts val="0"/>
-                </a:spcBef>
-                <a:spcAft>
-                  <a:spcPts val="0"/>
-                </a:spcAft>
-              </a:pPr>
-              <a:r>
-                <a:rPr sz="896" i="0" b="0">
-                  <a:solidFill>
-                    <a:srgbClr val="000000">
-                      <a:alpha val="100000"/>
-                    </a:srgbClr>
-                  </a:solidFill>
-                  <a:latin typeface="Arial"/>
-                  <a:cs typeface="Arial"/>
-                </a:rPr>
-                <a:t>15/31</a:t>
-              </a:r>
-            </a:p>
-          </p:txBody>
-        </p:sp>
-        <p:sp>
-          <p:nvSpPr>
-            <p:cNvPr id="67" name="tx67"/>
-            <p:cNvSpPr/>
-            <p:nvPr/>
-          </p:nvSpPr>
-          <p:spPr>
-            <a:xfrm>
-              <a:off x="5051456" y="2831416"/>
-              <a:ext cx="221101" cy="81381"/>
-            </a:xfrm>
-            <a:prstGeom prst="rect">
-              <a:avLst/>
-            </a:prstGeom>
-            <a:noFill/>
-          </p:spPr>
-          <p:txBody>
-            <a:bodyPr lIns="0" rIns="0" tIns="0" bIns="0" anchorCtr="1" anchor="ctr" wrap="none"/>
-            <a:lstStyle/>
-            <a:p>
-              <a:pPr algn="l" marL="0" marR="0" indent="0">
-                <a:spcBef>
-                  <a:spcPts val="0"/>
-                </a:spcBef>
-                <a:spcAft>
-                  <a:spcPts val="0"/>
-                </a:spcAft>
-              </a:pPr>
-              <a:r>
-                <a:rPr sz="896" i="0" b="0">
-                  <a:solidFill>
-                    <a:srgbClr val="000000">
-                      <a:alpha val="100000"/>
-                    </a:srgbClr>
-                  </a:solidFill>
-                  <a:latin typeface="Arial"/>
-                  <a:cs typeface="Arial"/>
-                </a:rPr>
-                <a:t>8/21</a:t>
-              </a:r>
-            </a:p>
-          </p:txBody>
-        </p:sp>
-        <p:sp>
-          <p:nvSpPr>
-            <p:cNvPr id="68" name="tx68"/>
-            <p:cNvSpPr/>
-            <p:nvPr/>
-          </p:nvSpPr>
-          <p:spPr>
-            <a:xfrm>
-              <a:off x="1445762" y="2122914"/>
-              <a:ext cx="347472" cy="81381"/>
-            </a:xfrm>
-            <a:prstGeom prst="rect">
-              <a:avLst/>
-            </a:prstGeom>
-            <a:noFill/>
-          </p:spPr>
-          <p:txBody>
-            <a:bodyPr lIns="0" rIns="0" tIns="0" bIns="0" anchorCtr="1" anchor="ctr" wrap="none"/>
-            <a:lstStyle/>
-            <a:p>
-              <a:pPr algn="l" marL="0" marR="0" indent="0">
-                <a:spcBef>
-                  <a:spcPts val="0"/>
-                </a:spcBef>
-                <a:spcAft>
-                  <a:spcPts val="0"/>
-                </a:spcAft>
-              </a:pPr>
-              <a:r>
-                <a:rPr sz="896" i="0" b="0">
-                  <a:solidFill>
-                    <a:srgbClr val="000000">
-                      <a:alpha val="100000"/>
-                    </a:srgbClr>
-                  </a:solidFill>
-                  <a:latin typeface="Arial"/>
-                  <a:cs typeface="Arial"/>
-                </a:rPr>
-                <a:t>56/218</a:t>
-              </a:r>
-            </a:p>
-          </p:txBody>
-        </p:sp>
-        <p:sp>
-          <p:nvSpPr>
-            <p:cNvPr id="69" name="tx69"/>
-            <p:cNvSpPr/>
-            <p:nvPr/>
-          </p:nvSpPr>
-          <p:spPr>
-            <a:xfrm>
-              <a:off x="2154264" y="2122914"/>
-              <a:ext cx="347472" cy="81381"/>
-            </a:xfrm>
-            <a:prstGeom prst="rect">
-              <a:avLst/>
-            </a:prstGeom>
-            <a:noFill/>
-          </p:spPr>
-          <p:txBody>
-            <a:bodyPr lIns="0" rIns="0" tIns="0" bIns="0" anchorCtr="1" anchor="ctr" wrap="none"/>
-            <a:lstStyle/>
-            <a:p>
-              <a:pPr algn="l" marL="0" marR="0" indent="0">
-                <a:spcBef>
-                  <a:spcPts val="0"/>
-                </a:spcBef>
-                <a:spcAft>
-                  <a:spcPts val="0"/>
-                </a:spcAft>
-              </a:pPr>
-              <a:r>
-                <a:rPr sz="896" i="0" b="0">
-                  <a:solidFill>
-                    <a:srgbClr val="000000">
-                      <a:alpha val="100000"/>
-                    </a:srgbClr>
-                  </a:solidFill>
-                  <a:latin typeface="Arial"/>
-                  <a:cs typeface="Arial"/>
-                </a:rPr>
-                <a:t>55/139</a:t>
-              </a:r>
-            </a:p>
-          </p:txBody>
-        </p:sp>
-        <p:sp>
-          <p:nvSpPr>
-            <p:cNvPr id="70" name="tx70"/>
-            <p:cNvSpPr/>
-            <p:nvPr/>
-          </p:nvSpPr>
-          <p:spPr>
-            <a:xfrm>
-              <a:off x="2894358" y="2122914"/>
-              <a:ext cx="284286" cy="81381"/>
-            </a:xfrm>
-            <a:prstGeom prst="rect">
-              <a:avLst/>
-            </a:prstGeom>
-            <a:noFill/>
-          </p:spPr>
-          <p:txBody>
-            <a:bodyPr lIns="0" rIns="0" tIns="0" bIns="0" anchorCtr="1" anchor="ctr" wrap="none"/>
-            <a:lstStyle/>
-            <a:p>
-              <a:pPr algn="l" marL="0" marR="0" indent="0">
-                <a:spcBef>
-                  <a:spcPts val="0"/>
-                </a:spcBef>
-                <a:spcAft>
-                  <a:spcPts val="0"/>
-                </a:spcAft>
-              </a:pPr>
-              <a:r>
-                <a:rPr sz="896" i="0" b="0">
-                  <a:solidFill>
-                    <a:srgbClr val="000000">
-                      <a:alpha val="100000"/>
-                    </a:srgbClr>
-                  </a:solidFill>
-                  <a:latin typeface="Arial"/>
-                  <a:cs typeface="Arial"/>
-                </a:rPr>
-                <a:t>18/98</a:t>
-              </a:r>
-            </a:p>
-          </p:txBody>
-        </p:sp>
-        <p:sp>
-          <p:nvSpPr>
-            <p:cNvPr id="71" name="tx71"/>
-            <p:cNvSpPr/>
-            <p:nvPr/>
-          </p:nvSpPr>
-          <p:spPr>
-            <a:xfrm>
-              <a:off x="3571267" y="2122914"/>
-              <a:ext cx="347472" cy="81381"/>
-            </a:xfrm>
-            <a:prstGeom prst="rect">
-              <a:avLst/>
-            </a:prstGeom>
-            <a:noFill/>
-          </p:spPr>
-          <p:txBody>
-            <a:bodyPr lIns="0" rIns="0" tIns="0" bIns="0" anchorCtr="1" anchor="ctr" wrap="none"/>
-            <a:lstStyle/>
-            <a:p>
-              <a:pPr algn="l" marL="0" marR="0" indent="0">
-                <a:spcBef>
-                  <a:spcPts val="0"/>
-                </a:spcBef>
-                <a:spcAft>
-                  <a:spcPts val="0"/>
-                </a:spcAft>
-              </a:pPr>
-              <a:r>
-                <a:rPr sz="896" i="0" b="0">
-                  <a:solidFill>
-                    <a:srgbClr val="000000">
-                      <a:alpha val="100000"/>
-                    </a:srgbClr>
-                  </a:solidFill>
-                  <a:latin typeface="Arial"/>
-                  <a:cs typeface="Arial"/>
-                </a:rPr>
-                <a:t>73/394</a:t>
-              </a:r>
-            </a:p>
-          </p:txBody>
-        </p:sp>
-        <p:sp>
-          <p:nvSpPr>
-            <p:cNvPr id="72" name="tx72"/>
-            <p:cNvSpPr/>
-            <p:nvPr/>
-          </p:nvSpPr>
-          <p:spPr>
-            <a:xfrm>
-              <a:off x="4279769" y="2122914"/>
-              <a:ext cx="347472" cy="81381"/>
-            </a:xfrm>
-            <a:prstGeom prst="rect">
-              <a:avLst/>
-            </a:prstGeom>
-            <a:noFill/>
-          </p:spPr>
-          <p:txBody>
-            <a:bodyPr lIns="0" rIns="0" tIns="0" bIns="0" anchorCtr="1" anchor="ctr" wrap="none"/>
-            <a:lstStyle/>
-            <a:p>
-              <a:pPr algn="l" marL="0" marR="0" indent="0">
-                <a:spcBef>
-                  <a:spcPts val="0"/>
-                </a:spcBef>
-                <a:spcAft>
-                  <a:spcPts val="0"/>
-                </a:spcAft>
-              </a:pPr>
-              <a:r>
-                <a:rPr sz="896" i="0" b="0">
-                  <a:solidFill>
-                    <a:srgbClr val="000000">
-                      <a:alpha val="100000"/>
-                    </a:srgbClr>
-                  </a:solidFill>
-                  <a:latin typeface="Arial"/>
-                  <a:cs typeface="Arial"/>
-                </a:rPr>
-                <a:t>73/185</a:t>
-              </a:r>
-            </a:p>
-          </p:txBody>
-        </p:sp>
-        <p:sp>
-          <p:nvSpPr>
-            <p:cNvPr id="73" name="tx73"/>
-            <p:cNvSpPr/>
-            <p:nvPr/>
-          </p:nvSpPr>
-          <p:spPr>
-            <a:xfrm>
-              <a:off x="4988271" y="2066912"/>
-              <a:ext cx="347472" cy="81381"/>
-            </a:xfrm>
-            <a:prstGeom prst="rect">
-              <a:avLst/>
-            </a:prstGeom>
-            <a:noFill/>
-          </p:spPr>
-          <p:txBody>
-            <a:bodyPr lIns="0" rIns="0" tIns="0" bIns="0" anchorCtr="1" anchor="ctr" wrap="none"/>
-            <a:lstStyle/>
-            <a:p>
-              <a:pPr algn="l" marL="0" marR="0" indent="0">
-                <a:spcBef>
-                  <a:spcPts val="0"/>
-                </a:spcBef>
-                <a:spcAft>
-                  <a:spcPts val="0"/>
-                </a:spcAft>
-              </a:pPr>
-              <a:r>
-                <a:rPr sz="896" i="0" b="0">
-                  <a:solidFill>
-                    <a:srgbClr val="000000">
-                      <a:alpha val="100000"/>
-                    </a:srgbClr>
-                  </a:solidFill>
-                  <a:latin typeface="Arial"/>
-                  <a:cs typeface="Arial"/>
-                </a:rPr>
-                <a:t>81/136</a:t>
-              </a:r>
-            </a:p>
-          </p:txBody>
-        </p:sp>
-        <p:sp>
-          <p:nvSpPr>
-            <p:cNvPr id="74" name="tx74"/>
-            <p:cNvSpPr/>
-            <p:nvPr/>
-          </p:nvSpPr>
-          <p:spPr>
-            <a:xfrm>
-              <a:off x="5139878" y="2178916"/>
-              <a:ext cx="44256" cy="81381"/>
-            </a:xfrm>
-            <a:prstGeom prst="rect">
-              <a:avLst/>
-            </a:prstGeom>
-            <a:noFill/>
-          </p:spPr>
-          <p:txBody>
-            <a:bodyPr lIns="0" rIns="0" tIns="0" bIns="0" anchorCtr="1" anchor="ctr" wrap="none"/>
-            <a:lstStyle/>
-            <a:p>
-              <a:pPr algn="l" marL="0" marR="0" indent="0">
-                <a:spcBef>
-                  <a:spcPts val="0"/>
-                </a:spcBef>
-                <a:spcAft>
-                  <a:spcPts val="0"/>
-                </a:spcAft>
-              </a:pPr>
-              <a:r>
-                <a:rPr sz="896" i="0" b="0">
-                  <a:solidFill>
-                    <a:srgbClr val="000000">
-                      <a:alpha val="100000"/>
-                    </a:srgbClr>
-                  </a:solidFill>
-                  <a:latin typeface="Arial"/>
-                  <a:cs typeface="Arial"/>
-                </a:rPr>
-                <a:t>*</a:t>
-              </a:r>
-            </a:p>
-          </p:txBody>
-        </p:sp>
-        <p:sp>
-          <p:nvSpPr>
-            <p:cNvPr id="75" name="tx75"/>
-            <p:cNvSpPr/>
-            <p:nvPr/>
-          </p:nvSpPr>
-          <p:spPr>
-            <a:xfrm>
-              <a:off x="1445762" y="1358410"/>
-              <a:ext cx="347472" cy="81381"/>
-            </a:xfrm>
-            <a:prstGeom prst="rect">
-              <a:avLst/>
-            </a:prstGeom>
-            <a:noFill/>
-          </p:spPr>
-          <p:txBody>
-            <a:bodyPr lIns="0" rIns="0" tIns="0" bIns="0" anchorCtr="1" anchor="ctr" wrap="none"/>
-            <a:lstStyle/>
-            <a:p>
-              <a:pPr algn="l" marL="0" marR="0" indent="0">
-                <a:spcBef>
-                  <a:spcPts val="0"/>
-                </a:spcBef>
-                <a:spcAft>
-                  <a:spcPts val="0"/>
-                </a:spcAft>
-              </a:pPr>
-              <a:r>
-                <a:rPr sz="896" i="0" b="0">
-                  <a:solidFill>
-                    <a:srgbClr val="000000">
-                      <a:alpha val="100000"/>
-                    </a:srgbClr>
-                  </a:solidFill>
-                  <a:latin typeface="Arial"/>
-                  <a:cs typeface="Arial"/>
-                </a:rPr>
-                <a:t>95/146</a:t>
-              </a:r>
-            </a:p>
-          </p:txBody>
-        </p:sp>
-        <p:sp>
-          <p:nvSpPr>
-            <p:cNvPr id="76" name="tx76"/>
-            <p:cNvSpPr/>
-            <p:nvPr/>
-          </p:nvSpPr>
-          <p:spPr>
-            <a:xfrm>
-              <a:off x="1603725" y="1470414"/>
-              <a:ext cx="31546" cy="81381"/>
-            </a:xfrm>
-            <a:prstGeom prst="rect">
-              <a:avLst/>
-            </a:prstGeom>
-            <a:noFill/>
-          </p:spPr>
-          <p:txBody>
-            <a:bodyPr lIns="0" rIns="0" tIns="0" bIns="0" anchorCtr="1" anchor="ctr" wrap="none"/>
-            <a:lstStyle/>
-            <a:p>
-              <a:pPr algn="l" marL="0" marR="0" indent="0">
-                <a:spcBef>
-                  <a:spcPts val="0"/>
-                </a:spcBef>
-                <a:spcAft>
-                  <a:spcPts val="0"/>
-                </a:spcAft>
-              </a:pPr>
-              <a:r>
-                <a:rPr sz="896" i="0" b="0">
-                  <a:solidFill>
-                    <a:srgbClr val="000000">
-                      <a:alpha val="100000"/>
-                    </a:srgbClr>
-                  </a:solidFill>
-                  <a:latin typeface="Arial"/>
-                  <a:cs typeface="Arial"/>
-                </a:rPr>
-                <a:t>.</a:t>
-              </a:r>
-            </a:p>
-          </p:txBody>
-        </p:sp>
-        <p:sp>
-          <p:nvSpPr>
-            <p:cNvPr id="77" name="tx77"/>
-            <p:cNvSpPr/>
-            <p:nvPr/>
-          </p:nvSpPr>
-          <p:spPr>
-            <a:xfrm>
-              <a:off x="2154264" y="1414412"/>
-              <a:ext cx="347472" cy="81381"/>
-            </a:xfrm>
-            <a:prstGeom prst="rect">
-              <a:avLst/>
-            </a:prstGeom>
-            <a:noFill/>
-          </p:spPr>
-          <p:txBody>
-            <a:bodyPr lIns="0" rIns="0" tIns="0" bIns="0" anchorCtr="1" anchor="ctr" wrap="none"/>
-            <a:lstStyle/>
-            <a:p>
-              <a:pPr algn="l" marL="0" marR="0" indent="0">
-                <a:spcBef>
-                  <a:spcPts val="0"/>
-                </a:spcBef>
-                <a:spcAft>
-                  <a:spcPts val="0"/>
-                </a:spcAft>
-              </a:pPr>
-              <a:r>
-                <a:rPr sz="896" i="0" b="0">
+                <a:rPr sz="1066" i="0" b="0">
                   <a:solidFill>
                     <a:srgbClr val="000000">
                       <a:alpha val="100000"/>
@@ -5125,14 +5168,14 @@
         </p:sp>
         <p:sp>
           <p:nvSpPr>
-            <p:cNvPr id="78" name="tx78"/>
-            <p:cNvSpPr/>
-            <p:nvPr/>
-          </p:nvSpPr>
-          <p:spPr>
-            <a:xfrm>
-              <a:off x="2894358" y="1414412"/>
-              <a:ext cx="284286" cy="81381"/>
+            <p:cNvPr id="79" name="tx79"/>
+            <p:cNvSpPr/>
+            <p:nvPr/>
+          </p:nvSpPr>
+          <p:spPr>
+            <a:xfrm>
+              <a:off x="2893271" y="1402622"/>
+              <a:ext cx="338602" cy="96926"/>
             </a:xfrm>
             <a:prstGeom prst="rect">
               <a:avLst/>
@@ -5152,7 +5195,7 @@
                 </a:spcAft>
               </a:pPr>
               <a:r>
-                <a:rPr sz="896" i="0" b="0">
+                <a:rPr sz="1066" i="0" b="0">
                   <a:solidFill>
                     <a:srgbClr val="000000">
                       <a:alpha val="100000"/>
@@ -5168,14 +5211,14 @@
         </p:sp>
         <p:sp>
           <p:nvSpPr>
-            <p:cNvPr id="79" name="tx79"/>
-            <p:cNvSpPr/>
-            <p:nvPr/>
-          </p:nvSpPr>
-          <p:spPr>
-            <a:xfrm>
-              <a:off x="3539675" y="1414412"/>
-              <a:ext cx="410657" cy="81381"/>
+            <p:cNvPr id="80" name="tx80"/>
+            <p:cNvSpPr/>
+            <p:nvPr/>
+          </p:nvSpPr>
+          <p:spPr>
+            <a:xfrm>
+              <a:off x="3519822" y="1402622"/>
+              <a:ext cx="489112" cy="96926"/>
             </a:xfrm>
             <a:prstGeom prst="rect">
               <a:avLst/>
@@ -5195,7 +5238,7 @@
                 </a:spcAft>
               </a:pPr>
               <a:r>
-                <a:rPr sz="896" i="0" b="0">
+                <a:rPr sz="1066" i="0" b="0">
                   <a:solidFill>
                     <a:srgbClr val="000000">
                       <a:alpha val="100000"/>
@@ -5211,14 +5254,14 @@
         </p:sp>
         <p:sp>
           <p:nvSpPr>
-            <p:cNvPr id="80" name="tx80"/>
-            <p:cNvSpPr/>
-            <p:nvPr/>
-          </p:nvSpPr>
-          <p:spPr>
-            <a:xfrm>
-              <a:off x="4248177" y="1414412"/>
-              <a:ext cx="410657" cy="81381"/>
+            <p:cNvPr id="81" name="tx81"/>
+            <p:cNvSpPr/>
+            <p:nvPr/>
+          </p:nvSpPr>
+          <p:spPr>
+            <a:xfrm>
+              <a:off x="4221628" y="1402622"/>
+              <a:ext cx="489112" cy="96926"/>
             </a:xfrm>
             <a:prstGeom prst="rect">
               <a:avLst/>
@@ -5238,7 +5281,7 @@
                 </a:spcAft>
               </a:pPr>
               <a:r>
-                <a:rPr sz="896" i="0" b="0">
+                <a:rPr sz="1066" i="0" b="0">
                   <a:solidFill>
                     <a:srgbClr val="000000">
                       <a:alpha val="100000"/>
@@ -5254,14 +5297,14 @@
         </p:sp>
         <p:sp>
           <p:nvSpPr>
-            <p:cNvPr id="81" name="tx81"/>
-            <p:cNvSpPr/>
-            <p:nvPr/>
-          </p:nvSpPr>
-          <p:spPr>
-            <a:xfrm>
-              <a:off x="4956678" y="1358410"/>
-              <a:ext cx="410657" cy="81381"/>
+            <p:cNvPr id="82" name="tx82"/>
+            <p:cNvSpPr/>
+            <p:nvPr/>
+          </p:nvSpPr>
+          <p:spPr>
+            <a:xfrm>
+              <a:off x="4923434" y="1335953"/>
+              <a:ext cx="489112" cy="96926"/>
             </a:xfrm>
             <a:prstGeom prst="rect">
               <a:avLst/>
@@ -5281,7 +5324,7 @@
                 </a:spcAft>
               </a:pPr>
               <a:r>
-                <a:rPr sz="896" i="0" b="0">
+                <a:rPr sz="1066" i="0" b="0">
                   <a:solidFill>
                     <a:srgbClr val="000000">
                       <a:alpha val="100000"/>
@@ -5297,14 +5340,14 @@
         </p:sp>
         <p:sp>
           <p:nvSpPr>
-            <p:cNvPr id="82" name="tx82"/>
-            <p:cNvSpPr/>
-            <p:nvPr/>
-          </p:nvSpPr>
-          <p:spPr>
-            <a:xfrm>
-              <a:off x="5139878" y="1470414"/>
-              <a:ext cx="44256" cy="81381"/>
+            <p:cNvPr id="83" name="tx83"/>
+            <p:cNvSpPr/>
+            <p:nvPr/>
+          </p:nvSpPr>
+          <p:spPr>
+            <a:xfrm>
+              <a:off x="5115321" y="1469292"/>
+              <a:ext cx="105338" cy="96926"/>
             </a:xfrm>
             <a:prstGeom prst="rect">
               <a:avLst/>
@@ -5324,7 +5367,7 @@
                 </a:spcAft>
               </a:pPr>
               <a:r>
-                <a:rPr sz="896" i="0" b="0">
+                <a:rPr sz="1066" i="0" b="0">
                   <a:solidFill>
                     <a:srgbClr val="000000">
                       <a:alpha val="100000"/>
@@ -5333,21 +5376,21 @@
                   <a:latin typeface="Arial"/>
                   <a:cs typeface="Arial"/>
                 </a:rPr>
-                <a:t>*</a:t>
+                <a:t>**</a:t>
               </a:r>
             </a:p>
           </p:txBody>
         </p:sp>
         <p:sp>
           <p:nvSpPr>
-            <p:cNvPr id="83" name="tx83"/>
-            <p:cNvSpPr/>
-            <p:nvPr/>
-          </p:nvSpPr>
-          <p:spPr>
-            <a:xfrm>
-              <a:off x="1007408" y="4957607"/>
-              <a:ext cx="124358" cy="80010"/>
+            <p:cNvPr id="84" name="tx84"/>
+            <p:cNvSpPr/>
+            <p:nvPr/>
+          </p:nvSpPr>
+          <p:spPr>
+            <a:xfrm>
+              <a:off x="1026931" y="4912384"/>
+              <a:ext cx="148315" cy="95463"/>
             </a:xfrm>
             <a:prstGeom prst="rect">
               <a:avLst/>
@@ -5367,7 +5410,7 @@
                 </a:spcAft>
               </a:pPr>
               <a:r>
-                <a:rPr sz="880" i="0" b="0">
+                <a:rPr sz="1050" i="0" b="0">
                   <a:solidFill>
                     <a:srgbClr val="000000">
                       <a:alpha val="100000"/>
@@ -5383,14 +5426,14 @@
         </p:sp>
         <p:sp>
           <p:nvSpPr>
-            <p:cNvPr id="84" name="tx84"/>
-            <p:cNvSpPr/>
-            <p:nvPr/>
-          </p:nvSpPr>
-          <p:spPr>
-            <a:xfrm>
-              <a:off x="1007408" y="4249105"/>
-              <a:ext cx="124358" cy="80010"/>
+            <p:cNvPr id="85" name="tx85"/>
+            <p:cNvSpPr/>
+            <p:nvPr/>
+          </p:nvSpPr>
+          <p:spPr>
+            <a:xfrm>
+              <a:off x="1026931" y="4210578"/>
+              <a:ext cx="148315" cy="95463"/>
             </a:xfrm>
             <a:prstGeom prst="rect">
               <a:avLst/>
@@ -5410,7 +5453,7 @@
                 </a:spcAft>
               </a:pPr>
               <a:r>
-                <a:rPr sz="880" i="0" b="0">
+                <a:rPr sz="1050" i="0" b="0">
                   <a:solidFill>
                     <a:srgbClr val="000000">
                       <a:alpha val="100000"/>
@@ -5426,14 +5469,14 @@
         </p:sp>
         <p:sp>
           <p:nvSpPr>
-            <p:cNvPr id="85" name="tx85"/>
-            <p:cNvSpPr/>
-            <p:nvPr/>
-          </p:nvSpPr>
-          <p:spPr>
-            <a:xfrm>
-              <a:off x="1007408" y="3540603"/>
-              <a:ext cx="124358" cy="80010"/>
+            <p:cNvPr id="86" name="tx86"/>
+            <p:cNvSpPr/>
+            <p:nvPr/>
+          </p:nvSpPr>
+          <p:spPr>
+            <a:xfrm>
+              <a:off x="1026931" y="3508772"/>
+              <a:ext cx="148315" cy="95463"/>
             </a:xfrm>
             <a:prstGeom prst="rect">
               <a:avLst/>
@@ -5453,7 +5496,7 @@
                 </a:spcAft>
               </a:pPr>
               <a:r>
-                <a:rPr sz="880" i="0" b="0">
+                <a:rPr sz="1050" i="0" b="0">
                   <a:solidFill>
                     <a:srgbClr val="000000">
                       <a:alpha val="100000"/>
@@ -5469,14 +5512,14 @@
         </p:sp>
         <p:sp>
           <p:nvSpPr>
-            <p:cNvPr id="86" name="tx86"/>
-            <p:cNvSpPr/>
-            <p:nvPr/>
-          </p:nvSpPr>
-          <p:spPr>
-            <a:xfrm>
-              <a:off x="1007408" y="2832102"/>
-              <a:ext cx="124358" cy="80010"/>
+            <p:cNvPr id="87" name="tx87"/>
+            <p:cNvSpPr/>
+            <p:nvPr/>
+          </p:nvSpPr>
+          <p:spPr>
+            <a:xfrm>
+              <a:off x="1026931" y="2806966"/>
+              <a:ext cx="148315" cy="95463"/>
             </a:xfrm>
             <a:prstGeom prst="rect">
               <a:avLst/>
@@ -5496,7 +5539,7 @@
                 </a:spcAft>
               </a:pPr>
               <a:r>
-                <a:rPr sz="880" i="0" b="0">
+                <a:rPr sz="1050" i="0" b="0">
                   <a:solidFill>
                     <a:srgbClr val="000000">
                       <a:alpha val="100000"/>
@@ -5512,14 +5555,14 @@
         </p:sp>
         <p:sp>
           <p:nvSpPr>
-            <p:cNvPr id="87" name="tx87"/>
-            <p:cNvSpPr/>
-            <p:nvPr/>
-          </p:nvSpPr>
-          <p:spPr>
-            <a:xfrm>
-              <a:off x="1007408" y="2123600"/>
-              <a:ext cx="124358" cy="80010"/>
+            <p:cNvPr id="88" name="tx88"/>
+            <p:cNvSpPr/>
+            <p:nvPr/>
+          </p:nvSpPr>
+          <p:spPr>
+            <a:xfrm>
+              <a:off x="1026931" y="2105160"/>
+              <a:ext cx="148315" cy="95463"/>
             </a:xfrm>
             <a:prstGeom prst="rect">
               <a:avLst/>
@@ -5539,7 +5582,7 @@
                 </a:spcAft>
               </a:pPr>
               <a:r>
-                <a:rPr sz="880" i="0" b="0">
+                <a:rPr sz="1050" i="0" b="0">
                   <a:solidFill>
                     <a:srgbClr val="000000">
                       <a:alpha val="100000"/>
@@ -5555,14 +5598,14 @@
         </p:sp>
         <p:sp>
           <p:nvSpPr>
-            <p:cNvPr id="88" name="tx88"/>
-            <p:cNvSpPr/>
-            <p:nvPr/>
-          </p:nvSpPr>
-          <p:spPr>
-            <a:xfrm>
-              <a:off x="1057243" y="1415098"/>
-              <a:ext cx="74523" cy="80010"/>
+            <p:cNvPr id="89" name="tx89"/>
+            <p:cNvSpPr/>
+            <p:nvPr/>
+          </p:nvSpPr>
+          <p:spPr>
+            <a:xfrm>
+              <a:off x="1086367" y="1403354"/>
+              <a:ext cx="88879" cy="95463"/>
             </a:xfrm>
             <a:prstGeom prst="rect">
               <a:avLst/>
@@ -5582,7 +5625,7 @@
                 </a:spcAft>
               </a:pPr>
               <a:r>
-                <a:rPr sz="880" i="0" b="0">
+                <a:rPr sz="1050" i="0" b="0">
                   <a:solidFill>
                     <a:srgbClr val="000000">
                       <a:alpha val="100000"/>
@@ -5598,14 +5641,14 @@
         </p:sp>
         <p:sp>
           <p:nvSpPr>
-            <p:cNvPr id="89" name="tx89"/>
-            <p:cNvSpPr/>
-            <p:nvPr/>
-          </p:nvSpPr>
-          <p:spPr>
-            <a:xfrm>
-              <a:off x="1557319" y="5485343"/>
-              <a:ext cx="124358" cy="80010"/>
+            <p:cNvPr id="90" name="tx90"/>
+            <p:cNvSpPr/>
+            <p:nvPr/>
+          </p:nvSpPr>
+          <p:spPr>
+            <a:xfrm>
+              <a:off x="1584802" y="5443829"/>
+              <a:ext cx="148315" cy="95463"/>
             </a:xfrm>
             <a:prstGeom prst="rect">
               <a:avLst/>
@@ -5625,7 +5668,7 @@
                 </a:spcAft>
               </a:pPr>
               <a:r>
-                <a:rPr sz="880" i="0" b="0">
+                <a:rPr sz="1050" i="0" b="0">
                   <a:solidFill>
                     <a:srgbClr val="000000">
                       <a:alpha val="100000"/>
@@ -5641,14 +5684,14 @@
         </p:sp>
         <p:sp>
           <p:nvSpPr>
-            <p:cNvPr id="90" name="tx90"/>
-            <p:cNvSpPr/>
-            <p:nvPr/>
-          </p:nvSpPr>
-          <p:spPr>
-            <a:xfrm>
-              <a:off x="2265821" y="5485343"/>
-              <a:ext cx="124358" cy="80010"/>
+            <p:cNvPr id="91" name="tx91"/>
+            <p:cNvSpPr/>
+            <p:nvPr/>
+          </p:nvSpPr>
+          <p:spPr>
+            <a:xfrm>
+              <a:off x="2286608" y="5443829"/>
+              <a:ext cx="148315" cy="95463"/>
             </a:xfrm>
             <a:prstGeom prst="rect">
               <a:avLst/>
@@ -5668,7 +5711,7 @@
                 </a:spcAft>
               </a:pPr>
               <a:r>
-                <a:rPr sz="880" i="0" b="0">
+                <a:rPr sz="1050" i="0" b="0">
                   <a:solidFill>
                     <a:srgbClr val="000000">
                       <a:alpha val="100000"/>
@@ -5684,14 +5727,14 @@
         </p:sp>
         <p:sp>
           <p:nvSpPr>
-            <p:cNvPr id="91" name="tx91"/>
-            <p:cNvSpPr/>
-            <p:nvPr/>
-          </p:nvSpPr>
-          <p:spPr>
-            <a:xfrm>
-              <a:off x="2974322" y="5485343"/>
-              <a:ext cx="124358" cy="80010"/>
+            <p:cNvPr id="92" name="tx92"/>
+            <p:cNvSpPr/>
+            <p:nvPr/>
+          </p:nvSpPr>
+          <p:spPr>
+            <a:xfrm>
+              <a:off x="2988414" y="5443829"/>
+              <a:ext cx="148315" cy="95463"/>
             </a:xfrm>
             <a:prstGeom prst="rect">
               <a:avLst/>
@@ -5711,7 +5754,7 @@
                 </a:spcAft>
               </a:pPr>
               <a:r>
-                <a:rPr sz="880" i="0" b="0">
+                <a:rPr sz="1050" i="0" b="0">
                   <a:solidFill>
                     <a:srgbClr val="000000">
                       <a:alpha val="100000"/>
@@ -5727,14 +5770,14 @@
         </p:sp>
         <p:sp>
           <p:nvSpPr>
-            <p:cNvPr id="92" name="tx92"/>
-            <p:cNvSpPr/>
-            <p:nvPr/>
-          </p:nvSpPr>
-          <p:spPr>
-            <a:xfrm>
-              <a:off x="3682824" y="5485343"/>
-              <a:ext cx="124358" cy="80010"/>
+            <p:cNvPr id="93" name="tx93"/>
+            <p:cNvSpPr/>
+            <p:nvPr/>
+          </p:nvSpPr>
+          <p:spPr>
+            <a:xfrm>
+              <a:off x="3690220" y="5443829"/>
+              <a:ext cx="148315" cy="95463"/>
             </a:xfrm>
             <a:prstGeom prst="rect">
               <a:avLst/>
@@ -5754,7 +5797,7 @@
                 </a:spcAft>
               </a:pPr>
               <a:r>
-                <a:rPr sz="880" i="0" b="0">
+                <a:rPr sz="1050" i="0" b="0">
                   <a:solidFill>
                     <a:srgbClr val="000000">
                       <a:alpha val="100000"/>
@@ -5770,14 +5813,14 @@
         </p:sp>
         <p:sp>
           <p:nvSpPr>
-            <p:cNvPr id="93" name="tx93"/>
-            <p:cNvSpPr/>
-            <p:nvPr/>
-          </p:nvSpPr>
-          <p:spPr>
-            <a:xfrm>
-              <a:off x="4391326" y="5485343"/>
-              <a:ext cx="124358" cy="80010"/>
+            <p:cNvPr id="94" name="tx94"/>
+            <p:cNvSpPr/>
+            <p:nvPr/>
+          </p:nvSpPr>
+          <p:spPr>
+            <a:xfrm>
+              <a:off x="4392026" y="5443829"/>
+              <a:ext cx="148315" cy="95463"/>
             </a:xfrm>
             <a:prstGeom prst="rect">
               <a:avLst/>
@@ -5797,7 +5840,7 @@
                 </a:spcAft>
               </a:pPr>
               <a:r>
-                <a:rPr sz="880" i="0" b="0">
+                <a:rPr sz="1050" i="0" b="0">
                   <a:solidFill>
                     <a:srgbClr val="000000">
                       <a:alpha val="100000"/>
@@ -5813,14 +5856,14 @@
         </p:sp>
         <p:sp>
           <p:nvSpPr>
-            <p:cNvPr id="94" name="tx94"/>
-            <p:cNvSpPr/>
-            <p:nvPr/>
-          </p:nvSpPr>
-          <p:spPr>
-            <a:xfrm>
-              <a:off x="5124745" y="5485343"/>
-              <a:ext cx="74523" cy="80010"/>
+            <p:cNvPr id="95" name="tx95"/>
+            <p:cNvSpPr/>
+            <p:nvPr/>
+          </p:nvSpPr>
+          <p:spPr>
+            <a:xfrm>
+              <a:off x="5123550" y="5443829"/>
+              <a:ext cx="88879" cy="95463"/>
             </a:xfrm>
             <a:prstGeom prst="rect">
               <a:avLst/>
@@ -5840,7 +5883,7 @@
                 </a:spcAft>
               </a:pPr>
               <a:r>
-                <a:rPr sz="880" i="0" b="0">
+                <a:rPr sz="1050" i="0" b="0">
                   <a:solidFill>
                     <a:srgbClr val="000000">
                       <a:alpha val="100000"/>
@@ -5856,14 +5899,14 @@
         </p:sp>
         <p:sp>
           <p:nvSpPr>
-            <p:cNvPr id="95" name="tx95"/>
-            <p:cNvSpPr/>
-            <p:nvPr/>
-          </p:nvSpPr>
-          <p:spPr>
-            <a:xfrm>
-              <a:off x="2355988" y="5623648"/>
-              <a:ext cx="1095085" cy="100035"/>
+            <p:cNvPr id="96" name="tx96"/>
+            <p:cNvSpPr/>
+            <p:nvPr/>
+          </p:nvSpPr>
+          <p:spPr>
+            <a:xfrm>
+              <a:off x="2238373" y="5602159"/>
+              <a:ext cx="1243858" cy="113659"/>
             </a:xfrm>
             <a:prstGeom prst="rect">
               <a:avLst/>
@@ -5883,7 +5926,7 @@
                 </a:spcAft>
               </a:pPr>
               <a:r>
-                <a:rPr sz="1100" i="1" b="0">
+                <a:rPr sz="1250" i="1" b="0">
                   <a:solidFill>
                     <a:srgbClr val="000000">
                       <a:alpha val="100000"/>
@@ -5899,14 +5942,14 @@
         </p:sp>
         <p:sp>
           <p:nvSpPr>
-            <p:cNvPr id="96" name="tx96"/>
-            <p:cNvSpPr/>
-            <p:nvPr/>
-          </p:nvSpPr>
-          <p:spPr>
-            <a:xfrm>
-              <a:off x="3462197" y="5623648"/>
-              <a:ext cx="963320" cy="100035"/>
+            <p:cNvPr id="97" name="tx97"/>
+            <p:cNvSpPr/>
+            <p:nvPr/>
+          </p:nvSpPr>
+          <p:spPr>
+            <a:xfrm>
+              <a:off x="3494864" y="5602159"/>
+              <a:ext cx="1093713" cy="113659"/>
             </a:xfrm>
             <a:prstGeom prst="rect">
               <a:avLst/>
@@ -5926,7 +5969,7 @@
                 </a:spcAft>
               </a:pPr>
               <a:r>
-                <a:rPr sz="1100" i="0" b="0">
+                <a:rPr sz="1250" i="0" b="0">
                   <a:solidFill>
                     <a:srgbClr val="000000">
                       <a:alpha val="100000"/>
@@ -5942,14 +5985,14 @@
         </p:sp>
         <p:sp>
           <p:nvSpPr>
-            <p:cNvPr id="97" name="tx97"/>
+            <p:cNvPr id="98" name="tx98"/>
             <p:cNvSpPr/>
             <p:nvPr/>
           </p:nvSpPr>
           <p:spPr>
             <a:xfrm rot="-5400000">
-              <a:off x="353702" y="3679152"/>
-              <a:ext cx="1020013" cy="100035"/>
+              <a:off x="289237" y="3719637"/>
+              <a:ext cx="1158636" cy="113659"/>
             </a:xfrm>
             <a:prstGeom prst="rect">
               <a:avLst/>
@@ -5969,7 +6012,7 @@
                 </a:spcAft>
               </a:pPr>
               <a:r>
-                <a:rPr sz="1100" i="1" b="0">
+                <a:rPr sz="1250" i="1" b="0">
                   <a:solidFill>
                     <a:srgbClr val="000000">
                       <a:alpha val="100000"/>
@@ -5985,14 +6028,14 @@
         </p:sp>
         <p:sp>
           <p:nvSpPr>
-            <p:cNvPr id="98" name="tx98"/>
+            <p:cNvPr id="99" name="tx99"/>
             <p:cNvSpPr/>
             <p:nvPr/>
           </p:nvSpPr>
           <p:spPr>
             <a:xfrm rot="-5400000">
-              <a:off x="366458" y="2660771"/>
-              <a:ext cx="994501" cy="100035"/>
+              <a:off x="304005" y="2563136"/>
+              <a:ext cx="1129101" cy="113659"/>
             </a:xfrm>
             <a:prstGeom prst="rect">
               <a:avLst/>
@@ -6012,7 +6055,7 @@
                 </a:spcAft>
               </a:pPr>
               <a:r>
-                <a:rPr sz="1100" i="0" b="0">
+                <a:rPr sz="1250" i="0" b="0">
                   <a:solidFill>
                     <a:srgbClr val="000000">
                       <a:alpha val="100000"/>
@@ -6028,13 +6071,13 @@
         </p:sp>
         <p:sp>
           <p:nvSpPr>
-            <p:cNvPr id="99" name="tx99"/>
-            <p:cNvSpPr/>
-            <p:nvPr/>
-          </p:nvSpPr>
-          <p:spPr>
-            <a:xfrm>
-              <a:off x="1590752" y="151156"/>
+            <p:cNvPr id="100" name="tx100"/>
+            <p:cNvSpPr/>
+            <p:nvPr/>
+          </p:nvSpPr>
+          <p:spPr>
+            <a:xfrm>
+              <a:off x="1613475" y="151156"/>
               <a:ext cx="984717" cy="81838"/>
             </a:xfrm>
             <a:prstGeom prst="rect">
@@ -6071,13 +6114,13 @@
         </p:sp>
         <p:sp>
           <p:nvSpPr>
-            <p:cNvPr id="100" name="tx100"/>
-            <p:cNvSpPr/>
-            <p:nvPr/>
-          </p:nvSpPr>
-          <p:spPr>
-            <a:xfrm>
-              <a:off x="1590752" y="274600"/>
+            <p:cNvPr id="101" name="tx101"/>
+            <p:cNvSpPr/>
+            <p:nvPr/>
+          </p:nvSpPr>
+          <p:spPr>
+            <a:xfrm>
+              <a:off x="1613475" y="274600"/>
               <a:ext cx="806866" cy="81838"/>
             </a:xfrm>
             <a:prstGeom prst="rect">
@@ -6114,7 +6157,7 @@
         </p:sp>
         <p:pic>
           <p:nvPicPr>
-            <p:cNvPr id="101" name="pic101"/>
+            <p:cNvPr id="102" name="pic102"/>
             <p:cNvPicPr/>
             <p:nvPr/>
           </p:nvPicPr>
@@ -6126,7 +6169,7 @@
           </p:blipFill>
           <p:spPr>
             <a:xfrm>
-              <a:off x="1590752" y="438007"/>
+              <a:off x="1613475" y="438007"/>
               <a:ext cx="3600000" cy="219455"/>
             </a:xfrm>
             <a:prstGeom prst="rect">
@@ -6136,13 +6179,13 @@
         </p:pic>
         <p:sp>
           <p:nvSpPr>
-            <p:cNvPr id="102" name="pl102"/>
-            <p:cNvSpPr/>
-            <p:nvPr/>
-          </p:nvSpPr>
-          <p:spPr>
-            <a:xfrm>
-              <a:off x="1596752" y="613572"/>
+            <p:cNvPr id="103" name="pl103"/>
+            <p:cNvSpPr/>
+            <p:nvPr/>
+          </p:nvSpPr>
+          <p:spPr>
+            <a:xfrm>
+              <a:off x="1619475" y="613572"/>
               <a:ext cx="0" cy="43891"/>
             </a:xfrm>
             <a:custGeom>
@@ -6176,13 +6219,13 @@
         </p:sp>
         <p:sp>
           <p:nvSpPr>
-            <p:cNvPr id="103" name="pl103"/>
-            <p:cNvSpPr/>
-            <p:nvPr/>
-          </p:nvSpPr>
-          <p:spPr>
-            <a:xfrm>
-              <a:off x="2279970" y="613572"/>
+            <p:cNvPr id="104" name="pl104"/>
+            <p:cNvSpPr/>
+            <p:nvPr/>
+          </p:nvSpPr>
+          <p:spPr>
+            <a:xfrm>
+              <a:off x="2302693" y="613572"/>
               <a:ext cx="0" cy="43891"/>
             </a:xfrm>
             <a:custGeom>
@@ -6216,13 +6259,13 @@
         </p:sp>
         <p:sp>
           <p:nvSpPr>
-            <p:cNvPr id="104" name="pl104"/>
-            <p:cNvSpPr/>
-            <p:nvPr/>
-          </p:nvSpPr>
-          <p:spPr>
-            <a:xfrm>
-              <a:off x="2963188" y="613572"/>
+            <p:cNvPr id="105" name="pl105"/>
+            <p:cNvSpPr/>
+            <p:nvPr/>
+          </p:nvSpPr>
+          <p:spPr>
+            <a:xfrm>
+              <a:off x="2985911" y="613572"/>
               <a:ext cx="0" cy="43891"/>
             </a:xfrm>
             <a:custGeom>
@@ -6256,13 +6299,13 @@
         </p:sp>
         <p:sp>
           <p:nvSpPr>
-            <p:cNvPr id="105" name="pl105"/>
-            <p:cNvSpPr/>
-            <p:nvPr/>
-          </p:nvSpPr>
-          <p:spPr>
-            <a:xfrm>
-              <a:off x="3646406" y="613572"/>
+            <p:cNvPr id="106" name="pl106"/>
+            <p:cNvSpPr/>
+            <p:nvPr/>
+          </p:nvSpPr>
+          <p:spPr>
+            <a:xfrm>
+              <a:off x="3669129" y="613572"/>
               <a:ext cx="0" cy="43891"/>
             </a:xfrm>
             <a:custGeom>
@@ -6296,13 +6339,13 @@
         </p:sp>
         <p:sp>
           <p:nvSpPr>
-            <p:cNvPr id="106" name="pl106"/>
-            <p:cNvSpPr/>
-            <p:nvPr/>
-          </p:nvSpPr>
-          <p:spPr>
-            <a:xfrm>
-              <a:off x="4329624" y="613572"/>
+            <p:cNvPr id="107" name="pl107"/>
+            <p:cNvSpPr/>
+            <p:nvPr/>
+          </p:nvSpPr>
+          <p:spPr>
+            <a:xfrm>
+              <a:off x="4352347" y="613572"/>
               <a:ext cx="0" cy="43891"/>
             </a:xfrm>
             <a:custGeom>
@@ -6336,13 +6379,13 @@
         </p:sp>
         <p:sp>
           <p:nvSpPr>
-            <p:cNvPr id="107" name="pl107"/>
-            <p:cNvSpPr/>
-            <p:nvPr/>
-          </p:nvSpPr>
-          <p:spPr>
-            <a:xfrm>
-              <a:off x="5012842" y="613572"/>
+            <p:cNvPr id="108" name="pl108"/>
+            <p:cNvSpPr/>
+            <p:nvPr/>
+          </p:nvSpPr>
+          <p:spPr>
+            <a:xfrm>
+              <a:off x="5035565" y="613572"/>
               <a:ext cx="0" cy="43891"/>
             </a:xfrm>
             <a:custGeom>
@@ -6376,13 +6419,13 @@
         </p:sp>
         <p:sp>
           <p:nvSpPr>
-            <p:cNvPr id="108" name="pl108"/>
-            <p:cNvSpPr/>
-            <p:nvPr/>
-          </p:nvSpPr>
-          <p:spPr>
-            <a:xfrm>
-              <a:off x="1596752" y="438007"/>
+            <p:cNvPr id="109" name="pl109"/>
+            <p:cNvSpPr/>
+            <p:nvPr/>
+          </p:nvSpPr>
+          <p:spPr>
+            <a:xfrm>
+              <a:off x="1619475" y="438007"/>
               <a:ext cx="0" cy="43891"/>
             </a:xfrm>
             <a:custGeom>
@@ -6416,13 +6459,13 @@
         </p:sp>
         <p:sp>
           <p:nvSpPr>
-            <p:cNvPr id="109" name="pl109"/>
-            <p:cNvSpPr/>
-            <p:nvPr/>
-          </p:nvSpPr>
-          <p:spPr>
-            <a:xfrm>
-              <a:off x="2279970" y="438007"/>
+            <p:cNvPr id="110" name="pl110"/>
+            <p:cNvSpPr/>
+            <p:nvPr/>
+          </p:nvSpPr>
+          <p:spPr>
+            <a:xfrm>
+              <a:off x="2302693" y="438007"/>
               <a:ext cx="0" cy="43891"/>
             </a:xfrm>
             <a:custGeom>
@@ -6456,13 +6499,13 @@
         </p:sp>
         <p:sp>
           <p:nvSpPr>
-            <p:cNvPr id="110" name="pl110"/>
-            <p:cNvSpPr/>
-            <p:nvPr/>
-          </p:nvSpPr>
-          <p:spPr>
-            <a:xfrm>
-              <a:off x="2963188" y="438007"/>
+            <p:cNvPr id="111" name="pl111"/>
+            <p:cNvSpPr/>
+            <p:nvPr/>
+          </p:nvSpPr>
+          <p:spPr>
+            <a:xfrm>
+              <a:off x="2985911" y="438007"/>
               <a:ext cx="0" cy="43891"/>
             </a:xfrm>
             <a:custGeom>
@@ -6496,13 +6539,13 @@
         </p:sp>
         <p:sp>
           <p:nvSpPr>
-            <p:cNvPr id="111" name="pl111"/>
-            <p:cNvSpPr/>
-            <p:nvPr/>
-          </p:nvSpPr>
-          <p:spPr>
-            <a:xfrm>
-              <a:off x="3646406" y="438007"/>
+            <p:cNvPr id="112" name="pl112"/>
+            <p:cNvSpPr/>
+            <p:nvPr/>
+          </p:nvSpPr>
+          <p:spPr>
+            <a:xfrm>
+              <a:off x="3669129" y="438007"/>
               <a:ext cx="0" cy="43891"/>
             </a:xfrm>
             <a:custGeom>
@@ -6536,13 +6579,13 @@
         </p:sp>
         <p:sp>
           <p:nvSpPr>
-            <p:cNvPr id="112" name="pl112"/>
-            <p:cNvSpPr/>
-            <p:nvPr/>
-          </p:nvSpPr>
-          <p:spPr>
-            <a:xfrm>
-              <a:off x="4329624" y="438007"/>
+            <p:cNvPr id="113" name="pl113"/>
+            <p:cNvSpPr/>
+            <p:nvPr/>
+          </p:nvSpPr>
+          <p:spPr>
+            <a:xfrm>
+              <a:off x="4352347" y="438007"/>
               <a:ext cx="0" cy="43891"/>
             </a:xfrm>
             <a:custGeom>
@@ -6576,13 +6619,13 @@
         </p:sp>
         <p:sp>
           <p:nvSpPr>
-            <p:cNvPr id="113" name="pl113"/>
-            <p:cNvSpPr/>
-            <p:nvPr/>
-          </p:nvSpPr>
-          <p:spPr>
-            <a:xfrm>
-              <a:off x="5012842" y="438007"/>
+            <p:cNvPr id="114" name="pl114"/>
+            <p:cNvSpPr/>
+            <p:nvPr/>
+          </p:nvSpPr>
+          <p:spPr>
+            <a:xfrm>
+              <a:off x="5035565" y="438007"/>
               <a:ext cx="0" cy="43891"/>
             </a:xfrm>
             <a:custGeom>
@@ -6616,13 +6659,13 @@
         </p:sp>
         <p:sp>
           <p:nvSpPr>
-            <p:cNvPr id="114" name="tx114"/>
-            <p:cNvSpPr/>
-            <p:nvPr/>
-          </p:nvSpPr>
-          <p:spPr>
-            <a:xfrm>
-              <a:off x="1497860" y="727052"/>
+            <p:cNvPr id="115" name="tx115"/>
+            <p:cNvSpPr/>
+            <p:nvPr/>
+          </p:nvSpPr>
+          <p:spPr>
+            <a:xfrm>
+              <a:off x="1520583" y="727052"/>
               <a:ext cx="197784" cy="72786"/>
             </a:xfrm>
             <a:prstGeom prst="rect">
@@ -6659,13 +6702,13 @@
         </p:sp>
         <p:sp>
           <p:nvSpPr>
-            <p:cNvPr id="115" name="tx115"/>
-            <p:cNvSpPr/>
-            <p:nvPr/>
-          </p:nvSpPr>
-          <p:spPr>
-            <a:xfrm>
-              <a:off x="2181078" y="727052"/>
+            <p:cNvPr id="116" name="tx116"/>
+            <p:cNvSpPr/>
+            <p:nvPr/>
+          </p:nvSpPr>
+          <p:spPr>
+            <a:xfrm>
+              <a:off x="2203801" y="727052"/>
               <a:ext cx="197784" cy="72786"/>
             </a:xfrm>
             <a:prstGeom prst="rect">
@@ -6702,13 +6745,13 @@
         </p:sp>
         <p:sp>
           <p:nvSpPr>
-            <p:cNvPr id="116" name="tx116"/>
-            <p:cNvSpPr/>
-            <p:nvPr/>
-          </p:nvSpPr>
-          <p:spPr>
-            <a:xfrm>
-              <a:off x="2864296" y="727052"/>
+            <p:cNvPr id="117" name="tx117"/>
+            <p:cNvSpPr/>
+            <p:nvPr/>
+          </p:nvSpPr>
+          <p:spPr>
+            <a:xfrm>
+              <a:off x="2887019" y="727052"/>
               <a:ext cx="197784" cy="72786"/>
             </a:xfrm>
             <a:prstGeom prst="rect">
@@ -6745,13 +6788,13 @@
         </p:sp>
         <p:sp>
           <p:nvSpPr>
-            <p:cNvPr id="117" name="tx117"/>
-            <p:cNvSpPr/>
-            <p:nvPr/>
-          </p:nvSpPr>
-          <p:spPr>
-            <a:xfrm>
-              <a:off x="3547514" y="727052"/>
+            <p:cNvPr id="118" name="tx118"/>
+            <p:cNvSpPr/>
+            <p:nvPr/>
+          </p:nvSpPr>
+          <p:spPr>
+            <a:xfrm>
+              <a:off x="3570237" y="727052"/>
               <a:ext cx="197784" cy="72786"/>
             </a:xfrm>
             <a:prstGeom prst="rect">
@@ -6788,13 +6831,13 @@
         </p:sp>
         <p:sp>
           <p:nvSpPr>
-            <p:cNvPr id="118" name="tx118"/>
-            <p:cNvSpPr/>
-            <p:nvPr/>
-          </p:nvSpPr>
-          <p:spPr>
-            <a:xfrm>
-              <a:off x="4230732" y="727052"/>
+            <p:cNvPr id="119" name="tx119"/>
+            <p:cNvSpPr/>
+            <p:nvPr/>
+          </p:nvSpPr>
+          <p:spPr>
+            <a:xfrm>
+              <a:off x="4253455" y="727052"/>
               <a:ext cx="197784" cy="72786"/>
             </a:xfrm>
             <a:prstGeom prst="rect">
@@ -6831,13 +6874,13 @@
         </p:sp>
         <p:sp>
           <p:nvSpPr>
-            <p:cNvPr id="119" name="tx119"/>
-            <p:cNvSpPr/>
-            <p:nvPr/>
-          </p:nvSpPr>
-          <p:spPr>
-            <a:xfrm>
-              <a:off x="4913950" y="727052"/>
+            <p:cNvPr id="120" name="tx120"/>
+            <p:cNvSpPr/>
+            <p:nvPr/>
+          </p:nvSpPr>
+          <p:spPr>
+            <a:xfrm>
+              <a:off x="4936673" y="727052"/>
               <a:ext cx="197784" cy="72786"/>
             </a:xfrm>
             <a:prstGeom prst="rect">

</xml_diff>